<commit_message>
fixed Linux release updated logo
</commit_message>
<xml_diff>
--- a/icons/icons.pptx
+++ b/icons/icons.pptx
@@ -259,7 +259,7 @@
           <a:p>
             <a:fld id="{86BFCE77-4DC5-4E93-9DE0-5BC6D0C526AF}" type="datetimeFigureOut">
               <a:rPr lang="en-US" smtClean="0"/>
-              <a:t>1/15/2026</a:t>
+              <a:t>3/9/2026</a:t>
             </a:fld>
             <a:endParaRPr lang="en-US"/>
           </a:p>
@@ -457,7 +457,7 @@
           <a:p>
             <a:fld id="{86BFCE77-4DC5-4E93-9DE0-5BC6D0C526AF}" type="datetimeFigureOut">
               <a:rPr lang="en-US" smtClean="0"/>
-              <a:t>1/15/2026</a:t>
+              <a:t>3/9/2026</a:t>
             </a:fld>
             <a:endParaRPr lang="en-US"/>
           </a:p>
@@ -665,7 +665,7 @@
           <a:p>
             <a:fld id="{86BFCE77-4DC5-4E93-9DE0-5BC6D0C526AF}" type="datetimeFigureOut">
               <a:rPr lang="en-US" smtClean="0"/>
-              <a:t>1/15/2026</a:t>
+              <a:t>3/9/2026</a:t>
             </a:fld>
             <a:endParaRPr lang="en-US"/>
           </a:p>
@@ -863,7 +863,7 @@
           <a:p>
             <a:fld id="{86BFCE77-4DC5-4E93-9DE0-5BC6D0C526AF}" type="datetimeFigureOut">
               <a:rPr lang="en-US" smtClean="0"/>
-              <a:t>1/15/2026</a:t>
+              <a:t>3/9/2026</a:t>
             </a:fld>
             <a:endParaRPr lang="en-US"/>
           </a:p>
@@ -1138,7 +1138,7 @@
           <a:p>
             <a:fld id="{86BFCE77-4DC5-4E93-9DE0-5BC6D0C526AF}" type="datetimeFigureOut">
               <a:rPr lang="en-US" smtClean="0"/>
-              <a:t>1/15/2026</a:t>
+              <a:t>3/9/2026</a:t>
             </a:fld>
             <a:endParaRPr lang="en-US"/>
           </a:p>
@@ -1403,7 +1403,7 @@
           <a:p>
             <a:fld id="{86BFCE77-4DC5-4E93-9DE0-5BC6D0C526AF}" type="datetimeFigureOut">
               <a:rPr lang="en-US" smtClean="0"/>
-              <a:t>1/15/2026</a:t>
+              <a:t>3/9/2026</a:t>
             </a:fld>
             <a:endParaRPr lang="en-US"/>
           </a:p>
@@ -1815,7 +1815,7 @@
           <a:p>
             <a:fld id="{86BFCE77-4DC5-4E93-9DE0-5BC6D0C526AF}" type="datetimeFigureOut">
               <a:rPr lang="en-US" smtClean="0"/>
-              <a:t>1/15/2026</a:t>
+              <a:t>3/9/2026</a:t>
             </a:fld>
             <a:endParaRPr lang="en-US"/>
           </a:p>
@@ -1956,7 +1956,7 @@
           <a:p>
             <a:fld id="{86BFCE77-4DC5-4E93-9DE0-5BC6D0C526AF}" type="datetimeFigureOut">
               <a:rPr lang="en-US" smtClean="0"/>
-              <a:t>1/15/2026</a:t>
+              <a:t>3/9/2026</a:t>
             </a:fld>
             <a:endParaRPr lang="en-US"/>
           </a:p>
@@ -2069,7 +2069,7 @@
           <a:p>
             <a:fld id="{86BFCE77-4DC5-4E93-9DE0-5BC6D0C526AF}" type="datetimeFigureOut">
               <a:rPr lang="en-US" smtClean="0"/>
-              <a:t>1/15/2026</a:t>
+              <a:t>3/9/2026</a:t>
             </a:fld>
             <a:endParaRPr lang="en-US"/>
           </a:p>
@@ -2380,7 +2380,7 @@
           <a:p>
             <a:fld id="{86BFCE77-4DC5-4E93-9DE0-5BC6D0C526AF}" type="datetimeFigureOut">
               <a:rPr lang="en-US" smtClean="0"/>
-              <a:t>1/15/2026</a:t>
+              <a:t>3/9/2026</a:t>
             </a:fld>
             <a:endParaRPr lang="en-US"/>
           </a:p>
@@ -2668,7 +2668,7 @@
           <a:p>
             <a:fld id="{86BFCE77-4DC5-4E93-9DE0-5BC6D0C526AF}" type="datetimeFigureOut">
               <a:rPr lang="en-US" smtClean="0"/>
-              <a:t>1/15/2026</a:t>
+              <a:t>3/9/2026</a:t>
             </a:fld>
             <a:endParaRPr lang="en-US"/>
           </a:p>
@@ -2909,7 +2909,7 @@
           <a:p>
             <a:fld id="{86BFCE77-4DC5-4E93-9DE0-5BC6D0C526AF}" type="datetimeFigureOut">
               <a:rPr lang="en-US" smtClean="0"/>
-              <a:t>1/15/2026</a:t>
+              <a:t>3/9/2026</a:t>
             </a:fld>
             <a:endParaRPr lang="en-US"/>
           </a:p>
@@ -4664,7 +4664,7 @@
                 <a:bodyPr rtlCol="0" anchor="ctr"/>
                 <a:lstStyle/>
                 <a:p>
-                  <a:endParaRPr lang="en-US"/>
+                  <a:endParaRPr lang="en-US" dirty="0"/>
                 </a:p>
               </p:txBody>
             </p:sp>
@@ -6298,6 +6298,3199 @@
             </p:txBody>
           </p:sp>
         </p:grpSp>
+      </p:grpSp>
+      <p:grpSp>
+        <p:nvGrpSpPr>
+          <p:cNvPr id="38" name="Group 37">
+            <a:extLst>
+              <a:ext uri="{FF2B5EF4-FFF2-40B4-BE49-F238E27FC236}">
+                <a16:creationId xmlns:a16="http://schemas.microsoft.com/office/drawing/2014/main" id="{624D3780-E1B7-4688-B806-947810B3F00C}"/>
+              </a:ext>
+            </a:extLst>
+          </p:cNvPr>
+          <p:cNvGrpSpPr/>
+          <p:nvPr/>
+        </p:nvGrpSpPr>
+        <p:grpSpPr>
+          <a:xfrm>
+            <a:off x="6835448" y="2660904"/>
+            <a:ext cx="771525" cy="768096"/>
+            <a:chOff x="1433715" y="1690310"/>
+            <a:chExt cx="771525" cy="768096"/>
+          </a:xfrm>
+        </p:grpSpPr>
+        <p:sp>
+          <p:nvSpPr>
+            <p:cNvPr id="39" name="TextBox 38">
+              <a:extLst>
+                <a:ext uri="{FF2B5EF4-FFF2-40B4-BE49-F238E27FC236}">
+                  <a16:creationId xmlns:a16="http://schemas.microsoft.com/office/drawing/2014/main" id="{6605449B-F0FD-4BD6-8BC1-B51EF0ECD584}"/>
+                </a:ext>
+              </a:extLst>
+            </p:cNvPr>
+            <p:cNvSpPr txBox="1"/>
+            <p:nvPr/>
+          </p:nvSpPr>
+          <p:spPr>
+            <a:xfrm>
+              <a:off x="1467365" y="1819896"/>
+              <a:ext cx="704224" cy="400110"/>
+            </a:xfrm>
+            <a:prstGeom prst="rect">
+              <a:avLst/>
+            </a:prstGeom>
+            <a:noFill/>
+          </p:spPr>
+          <p:txBody>
+            <a:bodyPr wrap="square" rtlCol="0">
+              <a:spAutoFit/>
+            </a:bodyPr>
+            <a:lstStyle/>
+            <a:p>
+              <a:r>
+                <a:rPr lang="en-US" sz="2000" b="1" dirty="0">
+                  <a:latin typeface="Sans Serif Collection" panose="020B0502040504020204" pitchFamily="34" charset="0"/>
+                  <a:ea typeface="Sans Serif Collection" panose="020B0502040504020204" pitchFamily="34" charset="0"/>
+                  <a:cs typeface="Sans Serif Collection" panose="020B0502040504020204" pitchFamily="34" charset="0"/>
+                </a:rPr>
+                <a:t>CVC</a:t>
+              </a:r>
+              <a:endParaRPr lang="en-US" sz="2800" b="1" dirty="0">
+                <a:latin typeface="Sans Serif Collection" panose="020B0502040504020204" pitchFamily="34" charset="0"/>
+                <a:ea typeface="Sans Serif Collection" panose="020B0502040504020204" pitchFamily="34" charset="0"/>
+                <a:cs typeface="Sans Serif Collection" panose="020B0502040504020204" pitchFamily="34" charset="0"/>
+              </a:endParaRPr>
+            </a:p>
+          </p:txBody>
+        </p:sp>
+        <p:sp>
+          <p:nvSpPr>
+            <p:cNvPr id="40" name="Freeform: Shape 39">
+              <a:extLst>
+                <a:ext uri="{FF2B5EF4-FFF2-40B4-BE49-F238E27FC236}">
+                  <a16:creationId xmlns:a16="http://schemas.microsoft.com/office/drawing/2014/main" id="{0100C3B0-A8C4-4B23-AADF-D18A40BF1DD0}"/>
+                </a:ext>
+              </a:extLst>
+            </p:cNvPr>
+            <p:cNvSpPr/>
+            <p:nvPr/>
+          </p:nvSpPr>
+          <p:spPr>
+            <a:xfrm>
+              <a:off x="1548448" y="2145499"/>
+              <a:ext cx="276225" cy="47625"/>
+            </a:xfrm>
+            <a:custGeom>
+              <a:avLst/>
+              <a:gdLst>
+                <a:gd name="connsiteX0" fmla="*/ 7144 w 276225"/>
+                <a:gd name="connsiteY0" fmla="*/ 7144 h 47625"/>
+                <a:gd name="connsiteX1" fmla="*/ 273844 w 276225"/>
+                <a:gd name="connsiteY1" fmla="*/ 7144 h 47625"/>
+                <a:gd name="connsiteX2" fmla="*/ 273844 w 276225"/>
+                <a:gd name="connsiteY2" fmla="*/ 45244 h 47625"/>
+                <a:gd name="connsiteX3" fmla="*/ 7144 w 276225"/>
+                <a:gd name="connsiteY3" fmla="*/ 45244 h 47625"/>
+              </a:gdLst>
+              <a:ahLst/>
+              <a:cxnLst>
+                <a:cxn ang="0">
+                  <a:pos x="connsiteX0" y="connsiteY0"/>
+                </a:cxn>
+                <a:cxn ang="0">
+                  <a:pos x="connsiteX1" y="connsiteY1"/>
+                </a:cxn>
+                <a:cxn ang="0">
+                  <a:pos x="connsiteX2" y="connsiteY2"/>
+                </a:cxn>
+                <a:cxn ang="0">
+                  <a:pos x="connsiteX3" y="connsiteY3"/>
+                </a:cxn>
+              </a:cxnLst>
+              <a:rect l="l" t="t" r="r" b="b"/>
+              <a:pathLst>
+                <a:path w="276225" h="47625">
+                  <a:moveTo>
+                    <a:pt x="7144" y="7144"/>
+                  </a:moveTo>
+                  <a:lnTo>
+                    <a:pt x="273844" y="7144"/>
+                  </a:lnTo>
+                  <a:lnTo>
+                    <a:pt x="273844" y="45244"/>
+                  </a:lnTo>
+                  <a:lnTo>
+                    <a:pt x="7144" y="45244"/>
+                  </a:lnTo>
+                  <a:close/>
+                </a:path>
+              </a:pathLst>
+            </a:custGeom>
+            <a:solidFill>
+              <a:schemeClr val="bg1">
+                <a:lumMod val="65000"/>
+              </a:schemeClr>
+            </a:solidFill>
+            <a:ln w="9525" cap="flat">
+              <a:noFill/>
+              <a:prstDash val="solid"/>
+              <a:miter/>
+            </a:ln>
+          </p:spPr>
+          <p:txBody>
+            <a:bodyPr rtlCol="0" anchor="ctr"/>
+            <a:lstStyle/>
+            <a:p>
+              <a:endParaRPr lang="en-US"/>
+            </a:p>
+          </p:txBody>
+        </p:sp>
+        <p:sp>
+          <p:nvSpPr>
+            <p:cNvPr id="41" name="Freeform: Shape 40">
+              <a:extLst>
+                <a:ext uri="{FF2B5EF4-FFF2-40B4-BE49-F238E27FC236}">
+                  <a16:creationId xmlns:a16="http://schemas.microsoft.com/office/drawing/2014/main" id="{0FAB7268-FB25-4990-93BE-CDDDE8F60EC3}"/>
+                </a:ext>
+              </a:extLst>
+            </p:cNvPr>
+            <p:cNvSpPr/>
+            <p:nvPr/>
+          </p:nvSpPr>
+          <p:spPr>
+            <a:xfrm>
+              <a:off x="1548448" y="2219317"/>
+              <a:ext cx="276225" cy="52388"/>
+            </a:xfrm>
+            <a:custGeom>
+              <a:avLst/>
+              <a:gdLst>
+                <a:gd name="connsiteX0" fmla="*/ 7144 w 276225"/>
+                <a:gd name="connsiteY0" fmla="*/ 7144 h 47625"/>
+                <a:gd name="connsiteX1" fmla="*/ 273844 w 276225"/>
+                <a:gd name="connsiteY1" fmla="*/ 7144 h 47625"/>
+                <a:gd name="connsiteX2" fmla="*/ 273844 w 276225"/>
+                <a:gd name="connsiteY2" fmla="*/ 45244 h 47625"/>
+                <a:gd name="connsiteX3" fmla="*/ 7144 w 276225"/>
+                <a:gd name="connsiteY3" fmla="*/ 45244 h 47625"/>
+              </a:gdLst>
+              <a:ahLst/>
+              <a:cxnLst>
+                <a:cxn ang="0">
+                  <a:pos x="connsiteX0" y="connsiteY0"/>
+                </a:cxn>
+                <a:cxn ang="0">
+                  <a:pos x="connsiteX1" y="connsiteY1"/>
+                </a:cxn>
+                <a:cxn ang="0">
+                  <a:pos x="connsiteX2" y="connsiteY2"/>
+                </a:cxn>
+                <a:cxn ang="0">
+                  <a:pos x="connsiteX3" y="connsiteY3"/>
+                </a:cxn>
+              </a:cxnLst>
+              <a:rect l="l" t="t" r="r" b="b"/>
+              <a:pathLst>
+                <a:path w="276225" h="47625">
+                  <a:moveTo>
+                    <a:pt x="7144" y="7144"/>
+                  </a:moveTo>
+                  <a:lnTo>
+                    <a:pt x="273844" y="7144"/>
+                  </a:lnTo>
+                  <a:lnTo>
+                    <a:pt x="273844" y="45244"/>
+                  </a:lnTo>
+                  <a:lnTo>
+                    <a:pt x="7144" y="45244"/>
+                  </a:lnTo>
+                  <a:close/>
+                </a:path>
+              </a:pathLst>
+            </a:custGeom>
+            <a:solidFill>
+              <a:schemeClr val="bg1">
+                <a:lumMod val="65000"/>
+              </a:schemeClr>
+            </a:solidFill>
+            <a:ln w="9525" cap="flat">
+              <a:noFill/>
+              <a:prstDash val="solid"/>
+              <a:miter/>
+            </a:ln>
+          </p:spPr>
+          <p:txBody>
+            <a:bodyPr rtlCol="0" anchor="ctr"/>
+            <a:lstStyle/>
+            <a:p>
+              <a:endParaRPr lang="en-US"/>
+            </a:p>
+          </p:txBody>
+        </p:sp>
+        <p:sp>
+          <p:nvSpPr>
+            <p:cNvPr id="42" name="Freeform: Shape 41">
+              <a:extLst>
+                <a:ext uri="{FF2B5EF4-FFF2-40B4-BE49-F238E27FC236}">
+                  <a16:creationId xmlns:a16="http://schemas.microsoft.com/office/drawing/2014/main" id="{562CA8D4-524E-4318-9CC1-EF10B3F96DC6}"/>
+                </a:ext>
+              </a:extLst>
+            </p:cNvPr>
+            <p:cNvSpPr/>
+            <p:nvPr/>
+          </p:nvSpPr>
+          <p:spPr>
+            <a:xfrm>
+              <a:off x="1433715" y="1690310"/>
+              <a:ext cx="771525" cy="768096"/>
+            </a:xfrm>
+            <a:custGeom>
+              <a:avLst/>
+              <a:gdLst>
+                <a:gd name="connsiteX0" fmla="*/ 7144 w 771525"/>
+                <a:gd name="connsiteY0" fmla="*/ 540544 h 542925"/>
+                <a:gd name="connsiteX1" fmla="*/ 769144 w 771525"/>
+                <a:gd name="connsiteY1" fmla="*/ 540544 h 542925"/>
+                <a:gd name="connsiteX2" fmla="*/ 769144 w 771525"/>
+                <a:gd name="connsiteY2" fmla="*/ 7144 h 542925"/>
+                <a:gd name="connsiteX3" fmla="*/ 7144 w 771525"/>
+                <a:gd name="connsiteY3" fmla="*/ 7144 h 542925"/>
+                <a:gd name="connsiteX4" fmla="*/ 7144 w 771525"/>
+                <a:gd name="connsiteY4" fmla="*/ 540544 h 542925"/>
+                <a:gd name="connsiteX5" fmla="*/ 711994 w 771525"/>
+                <a:gd name="connsiteY5" fmla="*/ 483394 h 542925"/>
+                <a:gd name="connsiteX6" fmla="*/ 64294 w 771525"/>
+                <a:gd name="connsiteY6" fmla="*/ 483394 h 542925"/>
+                <a:gd name="connsiteX7" fmla="*/ 64294 w 771525"/>
+                <a:gd name="connsiteY7" fmla="*/ 64294 h 542925"/>
+                <a:gd name="connsiteX8" fmla="*/ 711994 w 771525"/>
+                <a:gd name="connsiteY8" fmla="*/ 64294 h 542925"/>
+                <a:gd name="connsiteX9" fmla="*/ 711994 w 771525"/>
+                <a:gd name="connsiteY9" fmla="*/ 483394 h 542925"/>
+              </a:gdLst>
+              <a:ahLst/>
+              <a:cxnLst>
+                <a:cxn ang="0">
+                  <a:pos x="connsiteX0" y="connsiteY0"/>
+                </a:cxn>
+                <a:cxn ang="0">
+                  <a:pos x="connsiteX1" y="connsiteY1"/>
+                </a:cxn>
+                <a:cxn ang="0">
+                  <a:pos x="connsiteX2" y="connsiteY2"/>
+                </a:cxn>
+                <a:cxn ang="0">
+                  <a:pos x="connsiteX3" y="connsiteY3"/>
+                </a:cxn>
+                <a:cxn ang="0">
+                  <a:pos x="connsiteX4" y="connsiteY4"/>
+                </a:cxn>
+                <a:cxn ang="0">
+                  <a:pos x="connsiteX5" y="connsiteY5"/>
+                </a:cxn>
+                <a:cxn ang="0">
+                  <a:pos x="connsiteX6" y="connsiteY6"/>
+                </a:cxn>
+                <a:cxn ang="0">
+                  <a:pos x="connsiteX7" y="connsiteY7"/>
+                </a:cxn>
+                <a:cxn ang="0">
+                  <a:pos x="connsiteX8" y="connsiteY8"/>
+                </a:cxn>
+                <a:cxn ang="0">
+                  <a:pos x="connsiteX9" y="connsiteY9"/>
+                </a:cxn>
+              </a:cxnLst>
+              <a:rect l="l" t="t" r="r" b="b"/>
+              <a:pathLst>
+                <a:path w="771525" h="542925">
+                  <a:moveTo>
+                    <a:pt x="7144" y="540544"/>
+                  </a:moveTo>
+                  <a:lnTo>
+                    <a:pt x="769144" y="540544"/>
+                  </a:lnTo>
+                  <a:lnTo>
+                    <a:pt x="769144" y="7144"/>
+                  </a:lnTo>
+                  <a:lnTo>
+                    <a:pt x="7144" y="7144"/>
+                  </a:lnTo>
+                  <a:lnTo>
+                    <a:pt x="7144" y="540544"/>
+                  </a:lnTo>
+                  <a:close/>
+                  <a:moveTo>
+                    <a:pt x="711994" y="483394"/>
+                  </a:moveTo>
+                  <a:lnTo>
+                    <a:pt x="64294" y="483394"/>
+                  </a:lnTo>
+                  <a:lnTo>
+                    <a:pt x="64294" y="64294"/>
+                  </a:lnTo>
+                  <a:lnTo>
+                    <a:pt x="711994" y="64294"/>
+                  </a:lnTo>
+                  <a:lnTo>
+                    <a:pt x="711994" y="483394"/>
+                  </a:lnTo>
+                  <a:close/>
+                </a:path>
+              </a:pathLst>
+            </a:custGeom>
+            <a:solidFill>
+              <a:srgbClr val="F29C1F"/>
+            </a:solidFill>
+            <a:ln w="9525" cap="flat">
+              <a:noFill/>
+              <a:prstDash val="solid"/>
+              <a:miter/>
+            </a:ln>
+          </p:spPr>
+          <p:txBody>
+            <a:bodyPr rtlCol="0" anchor="ctr"/>
+            <a:lstStyle/>
+            <a:p>
+              <a:endParaRPr lang="en-US" dirty="0"/>
+            </a:p>
+          </p:txBody>
+        </p:sp>
+        <p:sp>
+          <p:nvSpPr>
+            <p:cNvPr id="43" name="Freeform: Shape 42">
+              <a:extLst>
+                <a:ext uri="{FF2B5EF4-FFF2-40B4-BE49-F238E27FC236}">
+                  <a16:creationId xmlns:a16="http://schemas.microsoft.com/office/drawing/2014/main" id="{B0683065-7294-4FE1-83A0-AC68C076C6F0}"/>
+                </a:ext>
+              </a:extLst>
+            </p:cNvPr>
+            <p:cNvSpPr/>
+            <p:nvPr/>
+          </p:nvSpPr>
+          <p:spPr>
+            <a:xfrm>
+              <a:off x="1880237" y="2089043"/>
+              <a:ext cx="256481" cy="256481"/>
+            </a:xfrm>
+            <a:custGeom>
+              <a:avLst/>
+              <a:gdLst>
+                <a:gd name="connsiteX0" fmla="*/ 130969 w 161925"/>
+                <a:gd name="connsiteY0" fmla="*/ 52864 h 161925"/>
+                <a:gd name="connsiteX1" fmla="*/ 134779 w 161925"/>
+                <a:gd name="connsiteY1" fmla="*/ 27146 h 161925"/>
+                <a:gd name="connsiteX2" fmla="*/ 110014 w 161925"/>
+                <a:gd name="connsiteY2" fmla="*/ 31909 h 161925"/>
+                <a:gd name="connsiteX3" fmla="*/ 100489 w 161925"/>
+                <a:gd name="connsiteY3" fmla="*/ 7144 h 161925"/>
+                <a:gd name="connsiteX4" fmla="*/ 81439 w 161925"/>
+                <a:gd name="connsiteY4" fmla="*/ 24289 h 161925"/>
+                <a:gd name="connsiteX5" fmla="*/ 61436 w 161925"/>
+                <a:gd name="connsiteY5" fmla="*/ 7144 h 161925"/>
+                <a:gd name="connsiteX6" fmla="*/ 52864 w 161925"/>
+                <a:gd name="connsiteY6" fmla="*/ 31909 h 161925"/>
+                <a:gd name="connsiteX7" fmla="*/ 27146 w 161925"/>
+                <a:gd name="connsiteY7" fmla="*/ 27146 h 161925"/>
+                <a:gd name="connsiteX8" fmla="*/ 31909 w 161925"/>
+                <a:gd name="connsiteY8" fmla="*/ 52864 h 161925"/>
+                <a:gd name="connsiteX9" fmla="*/ 7144 w 161925"/>
+                <a:gd name="connsiteY9" fmla="*/ 61436 h 161925"/>
+                <a:gd name="connsiteX10" fmla="*/ 24289 w 161925"/>
+                <a:gd name="connsiteY10" fmla="*/ 81439 h 161925"/>
+                <a:gd name="connsiteX11" fmla="*/ 7144 w 161925"/>
+                <a:gd name="connsiteY11" fmla="*/ 100489 h 161925"/>
+                <a:gd name="connsiteX12" fmla="*/ 31909 w 161925"/>
+                <a:gd name="connsiteY12" fmla="*/ 110014 h 161925"/>
+                <a:gd name="connsiteX13" fmla="*/ 27146 w 161925"/>
+                <a:gd name="connsiteY13" fmla="*/ 134779 h 161925"/>
+                <a:gd name="connsiteX14" fmla="*/ 52864 w 161925"/>
+                <a:gd name="connsiteY14" fmla="*/ 130969 h 161925"/>
+                <a:gd name="connsiteX15" fmla="*/ 61436 w 161925"/>
+                <a:gd name="connsiteY15" fmla="*/ 154781 h 161925"/>
+                <a:gd name="connsiteX16" fmla="*/ 81439 w 161925"/>
+                <a:gd name="connsiteY16" fmla="*/ 138589 h 161925"/>
+                <a:gd name="connsiteX17" fmla="*/ 100489 w 161925"/>
+                <a:gd name="connsiteY17" fmla="*/ 154781 h 161925"/>
+                <a:gd name="connsiteX18" fmla="*/ 110014 w 161925"/>
+                <a:gd name="connsiteY18" fmla="*/ 130969 h 161925"/>
+                <a:gd name="connsiteX19" fmla="*/ 134779 w 161925"/>
+                <a:gd name="connsiteY19" fmla="*/ 134779 h 161925"/>
+                <a:gd name="connsiteX20" fmla="*/ 130969 w 161925"/>
+                <a:gd name="connsiteY20" fmla="*/ 110014 h 161925"/>
+                <a:gd name="connsiteX21" fmla="*/ 154781 w 161925"/>
+                <a:gd name="connsiteY21" fmla="*/ 100489 h 161925"/>
+                <a:gd name="connsiteX22" fmla="*/ 138589 w 161925"/>
+                <a:gd name="connsiteY22" fmla="*/ 81439 h 161925"/>
+                <a:gd name="connsiteX23" fmla="*/ 154781 w 161925"/>
+                <a:gd name="connsiteY23" fmla="*/ 61436 h 161925"/>
+              </a:gdLst>
+              <a:ahLst/>
+              <a:cxnLst>
+                <a:cxn ang="0">
+                  <a:pos x="connsiteX0" y="connsiteY0"/>
+                </a:cxn>
+                <a:cxn ang="0">
+                  <a:pos x="connsiteX1" y="connsiteY1"/>
+                </a:cxn>
+                <a:cxn ang="0">
+                  <a:pos x="connsiteX2" y="connsiteY2"/>
+                </a:cxn>
+                <a:cxn ang="0">
+                  <a:pos x="connsiteX3" y="connsiteY3"/>
+                </a:cxn>
+                <a:cxn ang="0">
+                  <a:pos x="connsiteX4" y="connsiteY4"/>
+                </a:cxn>
+                <a:cxn ang="0">
+                  <a:pos x="connsiteX5" y="connsiteY5"/>
+                </a:cxn>
+                <a:cxn ang="0">
+                  <a:pos x="connsiteX6" y="connsiteY6"/>
+                </a:cxn>
+                <a:cxn ang="0">
+                  <a:pos x="connsiteX7" y="connsiteY7"/>
+                </a:cxn>
+                <a:cxn ang="0">
+                  <a:pos x="connsiteX8" y="connsiteY8"/>
+                </a:cxn>
+                <a:cxn ang="0">
+                  <a:pos x="connsiteX9" y="connsiteY9"/>
+                </a:cxn>
+                <a:cxn ang="0">
+                  <a:pos x="connsiteX10" y="connsiteY10"/>
+                </a:cxn>
+                <a:cxn ang="0">
+                  <a:pos x="connsiteX11" y="connsiteY11"/>
+                </a:cxn>
+                <a:cxn ang="0">
+                  <a:pos x="connsiteX12" y="connsiteY12"/>
+                </a:cxn>
+                <a:cxn ang="0">
+                  <a:pos x="connsiteX13" y="connsiteY13"/>
+                </a:cxn>
+                <a:cxn ang="0">
+                  <a:pos x="connsiteX14" y="connsiteY14"/>
+                </a:cxn>
+                <a:cxn ang="0">
+                  <a:pos x="connsiteX15" y="connsiteY15"/>
+                </a:cxn>
+                <a:cxn ang="0">
+                  <a:pos x="connsiteX16" y="connsiteY16"/>
+                </a:cxn>
+                <a:cxn ang="0">
+                  <a:pos x="connsiteX17" y="connsiteY17"/>
+                </a:cxn>
+                <a:cxn ang="0">
+                  <a:pos x="connsiteX18" y="connsiteY18"/>
+                </a:cxn>
+                <a:cxn ang="0">
+                  <a:pos x="connsiteX19" y="connsiteY19"/>
+                </a:cxn>
+                <a:cxn ang="0">
+                  <a:pos x="connsiteX20" y="connsiteY20"/>
+                </a:cxn>
+                <a:cxn ang="0">
+                  <a:pos x="connsiteX21" y="connsiteY21"/>
+                </a:cxn>
+                <a:cxn ang="0">
+                  <a:pos x="connsiteX22" y="connsiteY22"/>
+                </a:cxn>
+                <a:cxn ang="0">
+                  <a:pos x="connsiteX23" y="connsiteY23"/>
+                </a:cxn>
+              </a:cxnLst>
+              <a:rect l="l" t="t" r="r" b="b"/>
+              <a:pathLst>
+                <a:path w="161925" h="161925">
+                  <a:moveTo>
+                    <a:pt x="130969" y="52864"/>
+                  </a:moveTo>
+                  <a:lnTo>
+                    <a:pt x="134779" y="27146"/>
+                  </a:lnTo>
+                  <a:lnTo>
+                    <a:pt x="110014" y="31909"/>
+                  </a:lnTo>
+                  <a:lnTo>
+                    <a:pt x="100489" y="7144"/>
+                  </a:lnTo>
+                  <a:lnTo>
+                    <a:pt x="81439" y="24289"/>
+                  </a:lnTo>
+                  <a:lnTo>
+                    <a:pt x="61436" y="7144"/>
+                  </a:lnTo>
+                  <a:lnTo>
+                    <a:pt x="52864" y="31909"/>
+                  </a:lnTo>
+                  <a:lnTo>
+                    <a:pt x="27146" y="27146"/>
+                  </a:lnTo>
+                  <a:lnTo>
+                    <a:pt x="31909" y="52864"/>
+                  </a:lnTo>
+                  <a:lnTo>
+                    <a:pt x="7144" y="61436"/>
+                  </a:lnTo>
+                  <a:lnTo>
+                    <a:pt x="24289" y="81439"/>
+                  </a:lnTo>
+                  <a:lnTo>
+                    <a:pt x="7144" y="100489"/>
+                  </a:lnTo>
+                  <a:lnTo>
+                    <a:pt x="31909" y="110014"/>
+                  </a:lnTo>
+                  <a:lnTo>
+                    <a:pt x="27146" y="134779"/>
+                  </a:lnTo>
+                  <a:lnTo>
+                    <a:pt x="52864" y="130969"/>
+                  </a:lnTo>
+                  <a:lnTo>
+                    <a:pt x="61436" y="154781"/>
+                  </a:lnTo>
+                  <a:lnTo>
+                    <a:pt x="81439" y="138589"/>
+                  </a:lnTo>
+                  <a:lnTo>
+                    <a:pt x="100489" y="154781"/>
+                  </a:lnTo>
+                  <a:lnTo>
+                    <a:pt x="110014" y="130969"/>
+                  </a:lnTo>
+                  <a:lnTo>
+                    <a:pt x="134779" y="134779"/>
+                  </a:lnTo>
+                  <a:lnTo>
+                    <a:pt x="130969" y="110014"/>
+                  </a:lnTo>
+                  <a:lnTo>
+                    <a:pt x="154781" y="100489"/>
+                  </a:lnTo>
+                  <a:lnTo>
+                    <a:pt x="138589" y="81439"/>
+                  </a:lnTo>
+                  <a:lnTo>
+                    <a:pt x="154781" y="61436"/>
+                  </a:lnTo>
+                  <a:close/>
+                </a:path>
+              </a:pathLst>
+            </a:custGeom>
+            <a:solidFill>
+              <a:srgbClr val="FF5364"/>
+            </a:solidFill>
+            <a:ln w="9525" cap="flat">
+              <a:noFill/>
+              <a:prstDash val="solid"/>
+              <a:miter/>
+            </a:ln>
+          </p:spPr>
+          <p:txBody>
+            <a:bodyPr rtlCol="0" anchor="ctr"/>
+            <a:lstStyle/>
+            <a:p>
+              <a:endParaRPr lang="en-US"/>
+            </a:p>
+          </p:txBody>
+        </p:sp>
+        <p:sp>
+          <p:nvSpPr>
+            <p:cNvPr id="44" name="Freeform: Shape 43">
+              <a:extLst>
+                <a:ext uri="{FF2B5EF4-FFF2-40B4-BE49-F238E27FC236}">
+                  <a16:creationId xmlns:a16="http://schemas.microsoft.com/office/drawing/2014/main" id="{9A9FE4AC-F40D-43CB-A4AF-AF4552AF8801}"/>
+                </a:ext>
+              </a:extLst>
+            </p:cNvPr>
+            <p:cNvSpPr/>
+            <p:nvPr/>
+          </p:nvSpPr>
+          <p:spPr>
+            <a:xfrm>
+              <a:off x="1548446" y="2297899"/>
+              <a:ext cx="276225" cy="47625"/>
+            </a:xfrm>
+            <a:custGeom>
+              <a:avLst/>
+              <a:gdLst>
+                <a:gd name="connsiteX0" fmla="*/ 7144 w 276225"/>
+                <a:gd name="connsiteY0" fmla="*/ 7144 h 47625"/>
+                <a:gd name="connsiteX1" fmla="*/ 273844 w 276225"/>
+                <a:gd name="connsiteY1" fmla="*/ 7144 h 47625"/>
+                <a:gd name="connsiteX2" fmla="*/ 273844 w 276225"/>
+                <a:gd name="connsiteY2" fmla="*/ 45244 h 47625"/>
+                <a:gd name="connsiteX3" fmla="*/ 7144 w 276225"/>
+                <a:gd name="connsiteY3" fmla="*/ 45244 h 47625"/>
+              </a:gdLst>
+              <a:ahLst/>
+              <a:cxnLst>
+                <a:cxn ang="0">
+                  <a:pos x="connsiteX0" y="connsiteY0"/>
+                </a:cxn>
+                <a:cxn ang="0">
+                  <a:pos x="connsiteX1" y="connsiteY1"/>
+                </a:cxn>
+                <a:cxn ang="0">
+                  <a:pos x="connsiteX2" y="connsiteY2"/>
+                </a:cxn>
+                <a:cxn ang="0">
+                  <a:pos x="connsiteX3" y="connsiteY3"/>
+                </a:cxn>
+              </a:cxnLst>
+              <a:rect l="l" t="t" r="r" b="b"/>
+              <a:pathLst>
+                <a:path w="276225" h="47625">
+                  <a:moveTo>
+                    <a:pt x="7144" y="7144"/>
+                  </a:moveTo>
+                  <a:lnTo>
+                    <a:pt x="273844" y="7144"/>
+                  </a:lnTo>
+                  <a:lnTo>
+                    <a:pt x="273844" y="45244"/>
+                  </a:lnTo>
+                  <a:lnTo>
+                    <a:pt x="7144" y="45244"/>
+                  </a:lnTo>
+                  <a:close/>
+                </a:path>
+              </a:pathLst>
+            </a:custGeom>
+            <a:solidFill>
+              <a:schemeClr val="bg1">
+                <a:lumMod val="65000"/>
+              </a:schemeClr>
+            </a:solidFill>
+            <a:ln w="9525" cap="flat">
+              <a:noFill/>
+              <a:prstDash val="solid"/>
+              <a:miter/>
+            </a:ln>
+          </p:spPr>
+          <p:txBody>
+            <a:bodyPr rtlCol="0" anchor="ctr"/>
+            <a:lstStyle/>
+            <a:p>
+              <a:endParaRPr lang="en-US"/>
+            </a:p>
+          </p:txBody>
+        </p:sp>
+      </p:grpSp>
+      <p:grpSp>
+        <p:nvGrpSpPr>
+          <p:cNvPr id="7" name="Group 6">
+            <a:extLst>
+              <a:ext uri="{FF2B5EF4-FFF2-40B4-BE49-F238E27FC236}">
+                <a16:creationId xmlns:a16="http://schemas.microsoft.com/office/drawing/2014/main" id="{051E7AD4-F471-415D-A66B-880DDD6D4F35}"/>
+              </a:ext>
+            </a:extLst>
+          </p:cNvPr>
+          <p:cNvGrpSpPr/>
+          <p:nvPr/>
+        </p:nvGrpSpPr>
+        <p:grpSpPr>
+          <a:xfrm>
+            <a:off x="6852381" y="3897038"/>
+            <a:ext cx="771525" cy="768096"/>
+            <a:chOff x="6852381" y="3897038"/>
+            <a:chExt cx="771525" cy="768096"/>
+          </a:xfrm>
+        </p:grpSpPr>
+        <p:grpSp>
+          <p:nvGrpSpPr>
+            <p:cNvPr id="45" name="Group 44">
+              <a:extLst>
+                <a:ext uri="{FF2B5EF4-FFF2-40B4-BE49-F238E27FC236}">
+                  <a16:creationId xmlns:a16="http://schemas.microsoft.com/office/drawing/2014/main" id="{9AF57B96-A1D8-4864-8FBF-BF605A7318D7}"/>
+                </a:ext>
+              </a:extLst>
+            </p:cNvPr>
+            <p:cNvGrpSpPr/>
+            <p:nvPr/>
+          </p:nvGrpSpPr>
+          <p:grpSpPr>
+            <a:xfrm>
+              <a:off x="6852381" y="3897038"/>
+              <a:ext cx="771525" cy="768096"/>
+              <a:chOff x="1433715" y="1690310"/>
+              <a:chExt cx="771525" cy="768096"/>
+            </a:xfrm>
+          </p:grpSpPr>
+          <p:sp>
+            <p:nvSpPr>
+              <p:cNvPr id="46" name="TextBox 45">
+                <a:extLst>
+                  <a:ext uri="{FF2B5EF4-FFF2-40B4-BE49-F238E27FC236}">
+                    <a16:creationId xmlns:a16="http://schemas.microsoft.com/office/drawing/2014/main" id="{2A9C2F2E-44A2-48A1-923A-2DAF1DDB5DD7}"/>
+                  </a:ext>
+                </a:extLst>
+              </p:cNvPr>
+              <p:cNvSpPr txBox="1"/>
+              <p:nvPr/>
+            </p:nvSpPr>
+            <p:spPr>
+              <a:xfrm>
+                <a:off x="1467365" y="1819896"/>
+                <a:ext cx="704224" cy="400110"/>
+              </a:xfrm>
+              <a:prstGeom prst="rect">
+                <a:avLst/>
+              </a:prstGeom>
+              <a:noFill/>
+            </p:spPr>
+            <p:txBody>
+              <a:bodyPr wrap="square" rtlCol="0">
+                <a:spAutoFit/>
+              </a:bodyPr>
+              <a:lstStyle/>
+              <a:p>
+                <a:r>
+                  <a:rPr lang="en-US" sz="2000" b="1" dirty="0">
+                    <a:latin typeface="Sans Serif Collection" panose="020B0502040504020204" pitchFamily="34" charset="0"/>
+                    <a:ea typeface="Sans Serif Collection" panose="020B0502040504020204" pitchFamily="34" charset="0"/>
+                    <a:cs typeface="Sans Serif Collection" panose="020B0502040504020204" pitchFamily="34" charset="0"/>
+                  </a:rPr>
+                  <a:t>CVC</a:t>
+                </a:r>
+                <a:endParaRPr lang="en-US" sz="2800" b="1" dirty="0">
+                  <a:latin typeface="Sans Serif Collection" panose="020B0502040504020204" pitchFamily="34" charset="0"/>
+                  <a:ea typeface="Sans Serif Collection" panose="020B0502040504020204" pitchFamily="34" charset="0"/>
+                  <a:cs typeface="Sans Serif Collection" panose="020B0502040504020204" pitchFamily="34" charset="0"/>
+                </a:endParaRPr>
+              </a:p>
+            </p:txBody>
+          </p:sp>
+          <p:sp>
+            <p:nvSpPr>
+              <p:cNvPr id="56" name="Freeform: Shape 55">
+                <a:extLst>
+                  <a:ext uri="{FF2B5EF4-FFF2-40B4-BE49-F238E27FC236}">
+                    <a16:creationId xmlns:a16="http://schemas.microsoft.com/office/drawing/2014/main" id="{74719824-8A86-4EF4-97EC-5E1B5273E89C}"/>
+                  </a:ext>
+                </a:extLst>
+              </p:cNvPr>
+              <p:cNvSpPr/>
+              <p:nvPr/>
+            </p:nvSpPr>
+            <p:spPr>
+              <a:xfrm>
+                <a:off x="1548448" y="2145499"/>
+                <a:ext cx="276225" cy="47625"/>
+              </a:xfrm>
+              <a:custGeom>
+                <a:avLst/>
+                <a:gdLst>
+                  <a:gd name="connsiteX0" fmla="*/ 7144 w 276225"/>
+                  <a:gd name="connsiteY0" fmla="*/ 7144 h 47625"/>
+                  <a:gd name="connsiteX1" fmla="*/ 273844 w 276225"/>
+                  <a:gd name="connsiteY1" fmla="*/ 7144 h 47625"/>
+                  <a:gd name="connsiteX2" fmla="*/ 273844 w 276225"/>
+                  <a:gd name="connsiteY2" fmla="*/ 45244 h 47625"/>
+                  <a:gd name="connsiteX3" fmla="*/ 7144 w 276225"/>
+                  <a:gd name="connsiteY3" fmla="*/ 45244 h 47625"/>
+                </a:gdLst>
+                <a:ahLst/>
+                <a:cxnLst>
+                  <a:cxn ang="0">
+                    <a:pos x="connsiteX0" y="connsiteY0"/>
+                  </a:cxn>
+                  <a:cxn ang="0">
+                    <a:pos x="connsiteX1" y="connsiteY1"/>
+                  </a:cxn>
+                  <a:cxn ang="0">
+                    <a:pos x="connsiteX2" y="connsiteY2"/>
+                  </a:cxn>
+                  <a:cxn ang="0">
+                    <a:pos x="connsiteX3" y="connsiteY3"/>
+                  </a:cxn>
+                </a:cxnLst>
+                <a:rect l="l" t="t" r="r" b="b"/>
+                <a:pathLst>
+                  <a:path w="276225" h="47625">
+                    <a:moveTo>
+                      <a:pt x="7144" y="7144"/>
+                    </a:moveTo>
+                    <a:lnTo>
+                      <a:pt x="273844" y="7144"/>
+                    </a:lnTo>
+                    <a:lnTo>
+                      <a:pt x="273844" y="45244"/>
+                    </a:lnTo>
+                    <a:lnTo>
+                      <a:pt x="7144" y="45244"/>
+                    </a:lnTo>
+                    <a:close/>
+                  </a:path>
+                </a:pathLst>
+              </a:custGeom>
+              <a:solidFill>
+                <a:schemeClr val="bg1">
+                  <a:lumMod val="65000"/>
+                </a:schemeClr>
+              </a:solidFill>
+              <a:ln w="9525" cap="flat">
+                <a:noFill/>
+                <a:prstDash val="solid"/>
+                <a:miter/>
+              </a:ln>
+            </p:spPr>
+            <p:txBody>
+              <a:bodyPr rtlCol="0" anchor="ctr"/>
+              <a:lstStyle/>
+              <a:p>
+                <a:endParaRPr lang="en-US"/>
+              </a:p>
+            </p:txBody>
+          </p:sp>
+          <p:sp>
+            <p:nvSpPr>
+              <p:cNvPr id="57" name="Freeform: Shape 56">
+                <a:extLst>
+                  <a:ext uri="{FF2B5EF4-FFF2-40B4-BE49-F238E27FC236}">
+                    <a16:creationId xmlns:a16="http://schemas.microsoft.com/office/drawing/2014/main" id="{6703ECF0-1BF3-41BF-8E19-1D26E87BF3D1}"/>
+                  </a:ext>
+                </a:extLst>
+              </p:cNvPr>
+              <p:cNvSpPr/>
+              <p:nvPr/>
+            </p:nvSpPr>
+            <p:spPr>
+              <a:xfrm>
+                <a:off x="1548448" y="2219317"/>
+                <a:ext cx="276225" cy="52388"/>
+              </a:xfrm>
+              <a:custGeom>
+                <a:avLst/>
+                <a:gdLst>
+                  <a:gd name="connsiteX0" fmla="*/ 7144 w 276225"/>
+                  <a:gd name="connsiteY0" fmla="*/ 7144 h 47625"/>
+                  <a:gd name="connsiteX1" fmla="*/ 273844 w 276225"/>
+                  <a:gd name="connsiteY1" fmla="*/ 7144 h 47625"/>
+                  <a:gd name="connsiteX2" fmla="*/ 273844 w 276225"/>
+                  <a:gd name="connsiteY2" fmla="*/ 45244 h 47625"/>
+                  <a:gd name="connsiteX3" fmla="*/ 7144 w 276225"/>
+                  <a:gd name="connsiteY3" fmla="*/ 45244 h 47625"/>
+                </a:gdLst>
+                <a:ahLst/>
+                <a:cxnLst>
+                  <a:cxn ang="0">
+                    <a:pos x="connsiteX0" y="connsiteY0"/>
+                  </a:cxn>
+                  <a:cxn ang="0">
+                    <a:pos x="connsiteX1" y="connsiteY1"/>
+                  </a:cxn>
+                  <a:cxn ang="0">
+                    <a:pos x="connsiteX2" y="connsiteY2"/>
+                  </a:cxn>
+                  <a:cxn ang="0">
+                    <a:pos x="connsiteX3" y="connsiteY3"/>
+                  </a:cxn>
+                </a:cxnLst>
+                <a:rect l="l" t="t" r="r" b="b"/>
+                <a:pathLst>
+                  <a:path w="276225" h="47625">
+                    <a:moveTo>
+                      <a:pt x="7144" y="7144"/>
+                    </a:moveTo>
+                    <a:lnTo>
+                      <a:pt x="273844" y="7144"/>
+                    </a:lnTo>
+                    <a:lnTo>
+                      <a:pt x="273844" y="45244"/>
+                    </a:lnTo>
+                    <a:lnTo>
+                      <a:pt x="7144" y="45244"/>
+                    </a:lnTo>
+                    <a:close/>
+                  </a:path>
+                </a:pathLst>
+              </a:custGeom>
+              <a:solidFill>
+                <a:schemeClr val="bg1">
+                  <a:lumMod val="65000"/>
+                </a:schemeClr>
+              </a:solidFill>
+              <a:ln w="9525" cap="flat">
+                <a:noFill/>
+                <a:prstDash val="solid"/>
+                <a:miter/>
+              </a:ln>
+            </p:spPr>
+            <p:txBody>
+              <a:bodyPr rtlCol="0" anchor="ctr"/>
+              <a:lstStyle/>
+              <a:p>
+                <a:endParaRPr lang="en-US"/>
+              </a:p>
+            </p:txBody>
+          </p:sp>
+          <p:sp>
+            <p:nvSpPr>
+              <p:cNvPr id="59" name="Freeform: Shape 58">
+                <a:extLst>
+                  <a:ext uri="{FF2B5EF4-FFF2-40B4-BE49-F238E27FC236}">
+                    <a16:creationId xmlns:a16="http://schemas.microsoft.com/office/drawing/2014/main" id="{B6E2599A-503A-4011-BC2F-FF91CE4259DE}"/>
+                  </a:ext>
+                </a:extLst>
+              </p:cNvPr>
+              <p:cNvSpPr/>
+              <p:nvPr/>
+            </p:nvSpPr>
+            <p:spPr>
+              <a:xfrm>
+                <a:off x="1433715" y="1690310"/>
+                <a:ext cx="771525" cy="768096"/>
+              </a:xfrm>
+              <a:custGeom>
+                <a:avLst/>
+                <a:gdLst>
+                  <a:gd name="connsiteX0" fmla="*/ 7144 w 771525"/>
+                  <a:gd name="connsiteY0" fmla="*/ 540544 h 542925"/>
+                  <a:gd name="connsiteX1" fmla="*/ 769144 w 771525"/>
+                  <a:gd name="connsiteY1" fmla="*/ 540544 h 542925"/>
+                  <a:gd name="connsiteX2" fmla="*/ 769144 w 771525"/>
+                  <a:gd name="connsiteY2" fmla="*/ 7144 h 542925"/>
+                  <a:gd name="connsiteX3" fmla="*/ 7144 w 771525"/>
+                  <a:gd name="connsiteY3" fmla="*/ 7144 h 542925"/>
+                  <a:gd name="connsiteX4" fmla="*/ 7144 w 771525"/>
+                  <a:gd name="connsiteY4" fmla="*/ 540544 h 542925"/>
+                  <a:gd name="connsiteX5" fmla="*/ 711994 w 771525"/>
+                  <a:gd name="connsiteY5" fmla="*/ 483394 h 542925"/>
+                  <a:gd name="connsiteX6" fmla="*/ 64294 w 771525"/>
+                  <a:gd name="connsiteY6" fmla="*/ 483394 h 542925"/>
+                  <a:gd name="connsiteX7" fmla="*/ 64294 w 771525"/>
+                  <a:gd name="connsiteY7" fmla="*/ 64294 h 542925"/>
+                  <a:gd name="connsiteX8" fmla="*/ 711994 w 771525"/>
+                  <a:gd name="connsiteY8" fmla="*/ 64294 h 542925"/>
+                  <a:gd name="connsiteX9" fmla="*/ 711994 w 771525"/>
+                  <a:gd name="connsiteY9" fmla="*/ 483394 h 542925"/>
+                </a:gdLst>
+                <a:ahLst/>
+                <a:cxnLst>
+                  <a:cxn ang="0">
+                    <a:pos x="connsiteX0" y="connsiteY0"/>
+                  </a:cxn>
+                  <a:cxn ang="0">
+                    <a:pos x="connsiteX1" y="connsiteY1"/>
+                  </a:cxn>
+                  <a:cxn ang="0">
+                    <a:pos x="connsiteX2" y="connsiteY2"/>
+                  </a:cxn>
+                  <a:cxn ang="0">
+                    <a:pos x="connsiteX3" y="connsiteY3"/>
+                  </a:cxn>
+                  <a:cxn ang="0">
+                    <a:pos x="connsiteX4" y="connsiteY4"/>
+                  </a:cxn>
+                  <a:cxn ang="0">
+                    <a:pos x="connsiteX5" y="connsiteY5"/>
+                  </a:cxn>
+                  <a:cxn ang="0">
+                    <a:pos x="connsiteX6" y="connsiteY6"/>
+                  </a:cxn>
+                  <a:cxn ang="0">
+                    <a:pos x="connsiteX7" y="connsiteY7"/>
+                  </a:cxn>
+                  <a:cxn ang="0">
+                    <a:pos x="connsiteX8" y="connsiteY8"/>
+                  </a:cxn>
+                  <a:cxn ang="0">
+                    <a:pos x="connsiteX9" y="connsiteY9"/>
+                  </a:cxn>
+                </a:cxnLst>
+                <a:rect l="l" t="t" r="r" b="b"/>
+                <a:pathLst>
+                  <a:path w="771525" h="542925">
+                    <a:moveTo>
+                      <a:pt x="7144" y="540544"/>
+                    </a:moveTo>
+                    <a:lnTo>
+                      <a:pt x="769144" y="540544"/>
+                    </a:lnTo>
+                    <a:lnTo>
+                      <a:pt x="769144" y="7144"/>
+                    </a:lnTo>
+                    <a:lnTo>
+                      <a:pt x="7144" y="7144"/>
+                    </a:lnTo>
+                    <a:lnTo>
+                      <a:pt x="7144" y="540544"/>
+                    </a:lnTo>
+                    <a:close/>
+                    <a:moveTo>
+                      <a:pt x="711994" y="483394"/>
+                    </a:moveTo>
+                    <a:lnTo>
+                      <a:pt x="64294" y="483394"/>
+                    </a:lnTo>
+                    <a:lnTo>
+                      <a:pt x="64294" y="64294"/>
+                    </a:lnTo>
+                    <a:lnTo>
+                      <a:pt x="711994" y="64294"/>
+                    </a:lnTo>
+                    <a:lnTo>
+                      <a:pt x="711994" y="483394"/>
+                    </a:lnTo>
+                    <a:close/>
+                  </a:path>
+                </a:pathLst>
+              </a:custGeom>
+              <a:solidFill>
+                <a:srgbClr val="F29C1F"/>
+              </a:solidFill>
+              <a:ln w="9525" cap="flat">
+                <a:noFill/>
+                <a:prstDash val="solid"/>
+                <a:miter/>
+              </a:ln>
+            </p:spPr>
+            <p:txBody>
+              <a:bodyPr rtlCol="0" anchor="ctr"/>
+              <a:lstStyle/>
+              <a:p>
+                <a:endParaRPr lang="en-US" dirty="0"/>
+              </a:p>
+            </p:txBody>
+          </p:sp>
+          <p:sp>
+            <p:nvSpPr>
+              <p:cNvPr id="61" name="Freeform: Shape 60">
+                <a:extLst>
+                  <a:ext uri="{FF2B5EF4-FFF2-40B4-BE49-F238E27FC236}">
+                    <a16:creationId xmlns:a16="http://schemas.microsoft.com/office/drawing/2014/main" id="{6F08AF4A-1212-4618-BEF9-2E47789EAA67}"/>
+                  </a:ext>
+                </a:extLst>
+              </p:cNvPr>
+              <p:cNvSpPr/>
+              <p:nvPr/>
+            </p:nvSpPr>
+            <p:spPr>
+              <a:xfrm>
+                <a:off x="1880237" y="2089043"/>
+                <a:ext cx="256481" cy="256481"/>
+              </a:xfrm>
+              <a:custGeom>
+                <a:avLst/>
+                <a:gdLst>
+                  <a:gd name="connsiteX0" fmla="*/ 130969 w 161925"/>
+                  <a:gd name="connsiteY0" fmla="*/ 52864 h 161925"/>
+                  <a:gd name="connsiteX1" fmla="*/ 134779 w 161925"/>
+                  <a:gd name="connsiteY1" fmla="*/ 27146 h 161925"/>
+                  <a:gd name="connsiteX2" fmla="*/ 110014 w 161925"/>
+                  <a:gd name="connsiteY2" fmla="*/ 31909 h 161925"/>
+                  <a:gd name="connsiteX3" fmla="*/ 100489 w 161925"/>
+                  <a:gd name="connsiteY3" fmla="*/ 7144 h 161925"/>
+                  <a:gd name="connsiteX4" fmla="*/ 81439 w 161925"/>
+                  <a:gd name="connsiteY4" fmla="*/ 24289 h 161925"/>
+                  <a:gd name="connsiteX5" fmla="*/ 61436 w 161925"/>
+                  <a:gd name="connsiteY5" fmla="*/ 7144 h 161925"/>
+                  <a:gd name="connsiteX6" fmla="*/ 52864 w 161925"/>
+                  <a:gd name="connsiteY6" fmla="*/ 31909 h 161925"/>
+                  <a:gd name="connsiteX7" fmla="*/ 27146 w 161925"/>
+                  <a:gd name="connsiteY7" fmla="*/ 27146 h 161925"/>
+                  <a:gd name="connsiteX8" fmla="*/ 31909 w 161925"/>
+                  <a:gd name="connsiteY8" fmla="*/ 52864 h 161925"/>
+                  <a:gd name="connsiteX9" fmla="*/ 7144 w 161925"/>
+                  <a:gd name="connsiteY9" fmla="*/ 61436 h 161925"/>
+                  <a:gd name="connsiteX10" fmla="*/ 24289 w 161925"/>
+                  <a:gd name="connsiteY10" fmla="*/ 81439 h 161925"/>
+                  <a:gd name="connsiteX11" fmla="*/ 7144 w 161925"/>
+                  <a:gd name="connsiteY11" fmla="*/ 100489 h 161925"/>
+                  <a:gd name="connsiteX12" fmla="*/ 31909 w 161925"/>
+                  <a:gd name="connsiteY12" fmla="*/ 110014 h 161925"/>
+                  <a:gd name="connsiteX13" fmla="*/ 27146 w 161925"/>
+                  <a:gd name="connsiteY13" fmla="*/ 134779 h 161925"/>
+                  <a:gd name="connsiteX14" fmla="*/ 52864 w 161925"/>
+                  <a:gd name="connsiteY14" fmla="*/ 130969 h 161925"/>
+                  <a:gd name="connsiteX15" fmla="*/ 61436 w 161925"/>
+                  <a:gd name="connsiteY15" fmla="*/ 154781 h 161925"/>
+                  <a:gd name="connsiteX16" fmla="*/ 81439 w 161925"/>
+                  <a:gd name="connsiteY16" fmla="*/ 138589 h 161925"/>
+                  <a:gd name="connsiteX17" fmla="*/ 100489 w 161925"/>
+                  <a:gd name="connsiteY17" fmla="*/ 154781 h 161925"/>
+                  <a:gd name="connsiteX18" fmla="*/ 110014 w 161925"/>
+                  <a:gd name="connsiteY18" fmla="*/ 130969 h 161925"/>
+                  <a:gd name="connsiteX19" fmla="*/ 134779 w 161925"/>
+                  <a:gd name="connsiteY19" fmla="*/ 134779 h 161925"/>
+                  <a:gd name="connsiteX20" fmla="*/ 130969 w 161925"/>
+                  <a:gd name="connsiteY20" fmla="*/ 110014 h 161925"/>
+                  <a:gd name="connsiteX21" fmla="*/ 154781 w 161925"/>
+                  <a:gd name="connsiteY21" fmla="*/ 100489 h 161925"/>
+                  <a:gd name="connsiteX22" fmla="*/ 138589 w 161925"/>
+                  <a:gd name="connsiteY22" fmla="*/ 81439 h 161925"/>
+                  <a:gd name="connsiteX23" fmla="*/ 154781 w 161925"/>
+                  <a:gd name="connsiteY23" fmla="*/ 61436 h 161925"/>
+                </a:gdLst>
+                <a:ahLst/>
+                <a:cxnLst>
+                  <a:cxn ang="0">
+                    <a:pos x="connsiteX0" y="connsiteY0"/>
+                  </a:cxn>
+                  <a:cxn ang="0">
+                    <a:pos x="connsiteX1" y="connsiteY1"/>
+                  </a:cxn>
+                  <a:cxn ang="0">
+                    <a:pos x="connsiteX2" y="connsiteY2"/>
+                  </a:cxn>
+                  <a:cxn ang="0">
+                    <a:pos x="connsiteX3" y="connsiteY3"/>
+                  </a:cxn>
+                  <a:cxn ang="0">
+                    <a:pos x="connsiteX4" y="connsiteY4"/>
+                  </a:cxn>
+                  <a:cxn ang="0">
+                    <a:pos x="connsiteX5" y="connsiteY5"/>
+                  </a:cxn>
+                  <a:cxn ang="0">
+                    <a:pos x="connsiteX6" y="connsiteY6"/>
+                  </a:cxn>
+                  <a:cxn ang="0">
+                    <a:pos x="connsiteX7" y="connsiteY7"/>
+                  </a:cxn>
+                  <a:cxn ang="0">
+                    <a:pos x="connsiteX8" y="connsiteY8"/>
+                  </a:cxn>
+                  <a:cxn ang="0">
+                    <a:pos x="connsiteX9" y="connsiteY9"/>
+                  </a:cxn>
+                  <a:cxn ang="0">
+                    <a:pos x="connsiteX10" y="connsiteY10"/>
+                  </a:cxn>
+                  <a:cxn ang="0">
+                    <a:pos x="connsiteX11" y="connsiteY11"/>
+                  </a:cxn>
+                  <a:cxn ang="0">
+                    <a:pos x="connsiteX12" y="connsiteY12"/>
+                  </a:cxn>
+                  <a:cxn ang="0">
+                    <a:pos x="connsiteX13" y="connsiteY13"/>
+                  </a:cxn>
+                  <a:cxn ang="0">
+                    <a:pos x="connsiteX14" y="connsiteY14"/>
+                  </a:cxn>
+                  <a:cxn ang="0">
+                    <a:pos x="connsiteX15" y="connsiteY15"/>
+                  </a:cxn>
+                  <a:cxn ang="0">
+                    <a:pos x="connsiteX16" y="connsiteY16"/>
+                  </a:cxn>
+                  <a:cxn ang="0">
+                    <a:pos x="connsiteX17" y="connsiteY17"/>
+                  </a:cxn>
+                  <a:cxn ang="0">
+                    <a:pos x="connsiteX18" y="connsiteY18"/>
+                  </a:cxn>
+                  <a:cxn ang="0">
+                    <a:pos x="connsiteX19" y="connsiteY19"/>
+                  </a:cxn>
+                  <a:cxn ang="0">
+                    <a:pos x="connsiteX20" y="connsiteY20"/>
+                  </a:cxn>
+                  <a:cxn ang="0">
+                    <a:pos x="connsiteX21" y="connsiteY21"/>
+                  </a:cxn>
+                  <a:cxn ang="0">
+                    <a:pos x="connsiteX22" y="connsiteY22"/>
+                  </a:cxn>
+                  <a:cxn ang="0">
+                    <a:pos x="connsiteX23" y="connsiteY23"/>
+                  </a:cxn>
+                </a:cxnLst>
+                <a:rect l="l" t="t" r="r" b="b"/>
+                <a:pathLst>
+                  <a:path w="161925" h="161925">
+                    <a:moveTo>
+                      <a:pt x="130969" y="52864"/>
+                    </a:moveTo>
+                    <a:lnTo>
+                      <a:pt x="134779" y="27146"/>
+                    </a:lnTo>
+                    <a:lnTo>
+                      <a:pt x="110014" y="31909"/>
+                    </a:lnTo>
+                    <a:lnTo>
+                      <a:pt x="100489" y="7144"/>
+                    </a:lnTo>
+                    <a:lnTo>
+                      <a:pt x="81439" y="24289"/>
+                    </a:lnTo>
+                    <a:lnTo>
+                      <a:pt x="61436" y="7144"/>
+                    </a:lnTo>
+                    <a:lnTo>
+                      <a:pt x="52864" y="31909"/>
+                    </a:lnTo>
+                    <a:lnTo>
+                      <a:pt x="27146" y="27146"/>
+                    </a:lnTo>
+                    <a:lnTo>
+                      <a:pt x="31909" y="52864"/>
+                    </a:lnTo>
+                    <a:lnTo>
+                      <a:pt x="7144" y="61436"/>
+                    </a:lnTo>
+                    <a:lnTo>
+                      <a:pt x="24289" y="81439"/>
+                    </a:lnTo>
+                    <a:lnTo>
+                      <a:pt x="7144" y="100489"/>
+                    </a:lnTo>
+                    <a:lnTo>
+                      <a:pt x="31909" y="110014"/>
+                    </a:lnTo>
+                    <a:lnTo>
+                      <a:pt x="27146" y="134779"/>
+                    </a:lnTo>
+                    <a:lnTo>
+                      <a:pt x="52864" y="130969"/>
+                    </a:lnTo>
+                    <a:lnTo>
+                      <a:pt x="61436" y="154781"/>
+                    </a:lnTo>
+                    <a:lnTo>
+                      <a:pt x="81439" y="138589"/>
+                    </a:lnTo>
+                    <a:lnTo>
+                      <a:pt x="100489" y="154781"/>
+                    </a:lnTo>
+                    <a:lnTo>
+                      <a:pt x="110014" y="130969"/>
+                    </a:lnTo>
+                    <a:lnTo>
+                      <a:pt x="134779" y="134779"/>
+                    </a:lnTo>
+                    <a:lnTo>
+                      <a:pt x="130969" y="110014"/>
+                    </a:lnTo>
+                    <a:lnTo>
+                      <a:pt x="154781" y="100489"/>
+                    </a:lnTo>
+                    <a:lnTo>
+                      <a:pt x="138589" y="81439"/>
+                    </a:lnTo>
+                    <a:lnTo>
+                      <a:pt x="154781" y="61436"/>
+                    </a:lnTo>
+                    <a:close/>
+                  </a:path>
+                </a:pathLst>
+              </a:custGeom>
+              <a:solidFill>
+                <a:srgbClr val="FF5364"/>
+              </a:solidFill>
+              <a:ln w="9525" cap="flat">
+                <a:noFill/>
+                <a:prstDash val="solid"/>
+                <a:miter/>
+              </a:ln>
+            </p:spPr>
+            <p:txBody>
+              <a:bodyPr rtlCol="0" anchor="ctr"/>
+              <a:lstStyle/>
+              <a:p>
+                <a:endParaRPr lang="en-US"/>
+              </a:p>
+            </p:txBody>
+          </p:sp>
+          <p:sp>
+            <p:nvSpPr>
+              <p:cNvPr id="62" name="Freeform: Shape 61">
+                <a:extLst>
+                  <a:ext uri="{FF2B5EF4-FFF2-40B4-BE49-F238E27FC236}">
+                    <a16:creationId xmlns:a16="http://schemas.microsoft.com/office/drawing/2014/main" id="{8438516F-0FF5-45C3-A277-05A6791BC25F}"/>
+                  </a:ext>
+                </a:extLst>
+              </p:cNvPr>
+              <p:cNvSpPr/>
+              <p:nvPr/>
+            </p:nvSpPr>
+            <p:spPr>
+              <a:xfrm>
+                <a:off x="1548446" y="2297899"/>
+                <a:ext cx="276225" cy="47625"/>
+              </a:xfrm>
+              <a:custGeom>
+                <a:avLst/>
+                <a:gdLst>
+                  <a:gd name="connsiteX0" fmla="*/ 7144 w 276225"/>
+                  <a:gd name="connsiteY0" fmla="*/ 7144 h 47625"/>
+                  <a:gd name="connsiteX1" fmla="*/ 273844 w 276225"/>
+                  <a:gd name="connsiteY1" fmla="*/ 7144 h 47625"/>
+                  <a:gd name="connsiteX2" fmla="*/ 273844 w 276225"/>
+                  <a:gd name="connsiteY2" fmla="*/ 45244 h 47625"/>
+                  <a:gd name="connsiteX3" fmla="*/ 7144 w 276225"/>
+                  <a:gd name="connsiteY3" fmla="*/ 45244 h 47625"/>
+                </a:gdLst>
+                <a:ahLst/>
+                <a:cxnLst>
+                  <a:cxn ang="0">
+                    <a:pos x="connsiteX0" y="connsiteY0"/>
+                  </a:cxn>
+                  <a:cxn ang="0">
+                    <a:pos x="connsiteX1" y="connsiteY1"/>
+                  </a:cxn>
+                  <a:cxn ang="0">
+                    <a:pos x="connsiteX2" y="connsiteY2"/>
+                  </a:cxn>
+                  <a:cxn ang="0">
+                    <a:pos x="connsiteX3" y="connsiteY3"/>
+                  </a:cxn>
+                </a:cxnLst>
+                <a:rect l="l" t="t" r="r" b="b"/>
+                <a:pathLst>
+                  <a:path w="276225" h="47625">
+                    <a:moveTo>
+                      <a:pt x="7144" y="7144"/>
+                    </a:moveTo>
+                    <a:lnTo>
+                      <a:pt x="273844" y="7144"/>
+                    </a:lnTo>
+                    <a:lnTo>
+                      <a:pt x="273844" y="45244"/>
+                    </a:lnTo>
+                    <a:lnTo>
+                      <a:pt x="7144" y="45244"/>
+                    </a:lnTo>
+                    <a:close/>
+                  </a:path>
+                </a:pathLst>
+              </a:custGeom>
+              <a:solidFill>
+                <a:schemeClr val="bg1">
+                  <a:lumMod val="65000"/>
+                </a:schemeClr>
+              </a:solidFill>
+              <a:ln w="9525" cap="flat">
+                <a:noFill/>
+                <a:prstDash val="solid"/>
+                <a:miter/>
+              </a:ln>
+            </p:spPr>
+            <p:txBody>
+              <a:bodyPr rtlCol="0" anchor="ctr"/>
+              <a:lstStyle/>
+              <a:p>
+                <a:endParaRPr lang="en-US"/>
+              </a:p>
+            </p:txBody>
+          </p:sp>
+        </p:grpSp>
+        <p:sp>
+          <p:nvSpPr>
+            <p:cNvPr id="77" name="Graphic 23" descr="Checkmark">
+              <a:extLst>
+                <a:ext uri="{FF2B5EF4-FFF2-40B4-BE49-F238E27FC236}">
+                  <a16:creationId xmlns:a16="http://schemas.microsoft.com/office/drawing/2014/main" id="{DAD37AD5-C881-4B6B-A8B8-1AC682B50146}"/>
+                </a:ext>
+              </a:extLst>
+            </p:cNvPr>
+            <p:cNvSpPr>
+              <a:spLocks/>
+            </p:cNvSpPr>
+            <p:nvPr/>
+          </p:nvSpPr>
+          <p:spPr>
+            <a:xfrm>
+              <a:off x="7218927" y="4352227"/>
+              <a:ext cx="377156" cy="275614"/>
+            </a:xfrm>
+            <a:custGeom>
+              <a:avLst/>
+              <a:gdLst>
+                <a:gd name="connsiteX0" fmla="*/ 327473 w 377156"/>
+                <a:gd name="connsiteY0" fmla="*/ 21759 h 275614"/>
+                <a:gd name="connsiteX1" fmla="*/ 141796 w 377156"/>
+                <a:gd name="connsiteY1" fmla="*/ 197282 h 275614"/>
+                <a:gd name="connsiteX2" fmla="*/ 52584 w 377156"/>
+                <a:gd name="connsiteY2" fmla="*/ 105894 h 275614"/>
+                <a:gd name="connsiteX3" fmla="*/ 21759 w 377156"/>
+                <a:gd name="connsiteY3" fmla="*/ 135268 h 275614"/>
+                <a:gd name="connsiteX4" fmla="*/ 140346 w 377156"/>
+                <a:gd name="connsiteY4" fmla="*/ 257119 h 275614"/>
+                <a:gd name="connsiteX5" fmla="*/ 171533 w 377156"/>
+                <a:gd name="connsiteY5" fmla="*/ 228107 h 275614"/>
+                <a:gd name="connsiteX6" fmla="*/ 356848 w 377156"/>
+                <a:gd name="connsiteY6" fmla="*/ 52222 h 275614"/>
+              </a:gdLst>
+              <a:ahLst/>
+              <a:cxnLst>
+                <a:cxn ang="0">
+                  <a:pos x="connsiteX0" y="connsiteY0"/>
+                </a:cxn>
+                <a:cxn ang="0">
+                  <a:pos x="connsiteX1" y="connsiteY1"/>
+                </a:cxn>
+                <a:cxn ang="0">
+                  <a:pos x="connsiteX2" y="connsiteY2"/>
+                </a:cxn>
+                <a:cxn ang="0">
+                  <a:pos x="connsiteX3" y="connsiteY3"/>
+                </a:cxn>
+                <a:cxn ang="0">
+                  <a:pos x="connsiteX4" y="connsiteY4"/>
+                </a:cxn>
+                <a:cxn ang="0">
+                  <a:pos x="connsiteX5" y="connsiteY5"/>
+                </a:cxn>
+                <a:cxn ang="0">
+                  <a:pos x="connsiteX6" y="connsiteY6"/>
+                </a:cxn>
+              </a:cxnLst>
+              <a:rect l="l" t="t" r="r" b="b"/>
+              <a:pathLst>
+                <a:path w="377156" h="275614">
+                  <a:moveTo>
+                    <a:pt x="327473" y="21759"/>
+                  </a:moveTo>
+                  <a:lnTo>
+                    <a:pt x="141796" y="197282"/>
+                  </a:lnTo>
+                  <a:lnTo>
+                    <a:pt x="52584" y="105894"/>
+                  </a:lnTo>
+                  <a:lnTo>
+                    <a:pt x="21759" y="135268"/>
+                  </a:lnTo>
+                  <a:lnTo>
+                    <a:pt x="140346" y="257119"/>
+                  </a:lnTo>
+                  <a:lnTo>
+                    <a:pt x="171533" y="228107"/>
+                  </a:lnTo>
+                  <a:lnTo>
+                    <a:pt x="356848" y="52222"/>
+                  </a:lnTo>
+                  <a:close/>
+                </a:path>
+              </a:pathLst>
+            </a:custGeom>
+            <a:solidFill>
+              <a:srgbClr val="00B050"/>
+            </a:solidFill>
+            <a:ln w="76200" cap="flat">
+              <a:noFill/>
+              <a:prstDash val="solid"/>
+              <a:miter/>
+            </a:ln>
+            <a:effectLst/>
+          </p:spPr>
+          <p:txBody>
+            <a:bodyPr rtlCol="0" anchor="ctr"/>
+            <a:lstStyle/>
+            <a:p>
+              <a:endParaRPr lang="en-US" dirty="0"/>
+            </a:p>
+          </p:txBody>
+        </p:sp>
+      </p:grpSp>
+      <p:grpSp>
+        <p:nvGrpSpPr>
+          <p:cNvPr id="4" name="Group 3">
+            <a:extLst>
+              <a:ext uri="{FF2B5EF4-FFF2-40B4-BE49-F238E27FC236}">
+                <a16:creationId xmlns:a16="http://schemas.microsoft.com/office/drawing/2014/main" id="{0D93120D-3A3E-44B5-91BF-52506992B027}"/>
+              </a:ext>
+            </a:extLst>
+          </p:cNvPr>
+          <p:cNvGrpSpPr/>
+          <p:nvPr/>
+        </p:nvGrpSpPr>
+        <p:grpSpPr>
+          <a:xfrm>
+            <a:off x="8325581" y="3897038"/>
+            <a:ext cx="774744" cy="768096"/>
+            <a:chOff x="8325581" y="3897038"/>
+            <a:chExt cx="774744" cy="768096"/>
+          </a:xfrm>
+        </p:grpSpPr>
+        <p:grpSp>
+          <p:nvGrpSpPr>
+            <p:cNvPr id="63" name="Group 62">
+              <a:extLst>
+                <a:ext uri="{FF2B5EF4-FFF2-40B4-BE49-F238E27FC236}">
+                  <a16:creationId xmlns:a16="http://schemas.microsoft.com/office/drawing/2014/main" id="{34DE79AF-A72B-4AF0-8FB0-83BE9020D47F}"/>
+                </a:ext>
+              </a:extLst>
+            </p:cNvPr>
+            <p:cNvGrpSpPr/>
+            <p:nvPr/>
+          </p:nvGrpSpPr>
+          <p:grpSpPr>
+            <a:xfrm>
+              <a:off x="8325581" y="3897038"/>
+              <a:ext cx="771525" cy="768096"/>
+              <a:chOff x="1433715" y="1690310"/>
+              <a:chExt cx="771525" cy="768096"/>
+            </a:xfrm>
+          </p:grpSpPr>
+          <p:sp>
+            <p:nvSpPr>
+              <p:cNvPr id="64" name="TextBox 63">
+                <a:extLst>
+                  <a:ext uri="{FF2B5EF4-FFF2-40B4-BE49-F238E27FC236}">
+                    <a16:creationId xmlns:a16="http://schemas.microsoft.com/office/drawing/2014/main" id="{0BF778F6-8E4B-4648-9872-529C5B948C80}"/>
+                  </a:ext>
+                </a:extLst>
+              </p:cNvPr>
+              <p:cNvSpPr txBox="1"/>
+              <p:nvPr/>
+            </p:nvSpPr>
+            <p:spPr>
+              <a:xfrm>
+                <a:off x="1467365" y="1819896"/>
+                <a:ext cx="704224" cy="400110"/>
+              </a:xfrm>
+              <a:prstGeom prst="rect">
+                <a:avLst/>
+              </a:prstGeom>
+              <a:noFill/>
+            </p:spPr>
+            <p:txBody>
+              <a:bodyPr wrap="square" rtlCol="0">
+                <a:spAutoFit/>
+              </a:bodyPr>
+              <a:lstStyle/>
+              <a:p>
+                <a:r>
+                  <a:rPr lang="en-US" sz="2000" b="1" dirty="0">
+                    <a:latin typeface="Sans Serif Collection" panose="020B0502040504020204" pitchFamily="34" charset="0"/>
+                    <a:ea typeface="Sans Serif Collection" panose="020B0502040504020204" pitchFamily="34" charset="0"/>
+                    <a:cs typeface="Sans Serif Collection" panose="020B0502040504020204" pitchFamily="34" charset="0"/>
+                  </a:rPr>
+                  <a:t>CVC</a:t>
+                </a:r>
+                <a:endParaRPr lang="en-US" sz="2800" b="1" dirty="0">
+                  <a:latin typeface="Sans Serif Collection" panose="020B0502040504020204" pitchFamily="34" charset="0"/>
+                  <a:ea typeface="Sans Serif Collection" panose="020B0502040504020204" pitchFamily="34" charset="0"/>
+                  <a:cs typeface="Sans Serif Collection" panose="020B0502040504020204" pitchFamily="34" charset="0"/>
+                </a:endParaRPr>
+              </a:p>
+            </p:txBody>
+          </p:sp>
+          <p:sp>
+            <p:nvSpPr>
+              <p:cNvPr id="65" name="Freeform: Shape 64">
+                <a:extLst>
+                  <a:ext uri="{FF2B5EF4-FFF2-40B4-BE49-F238E27FC236}">
+                    <a16:creationId xmlns:a16="http://schemas.microsoft.com/office/drawing/2014/main" id="{33F6B729-134F-43A8-AC11-9418032F4682}"/>
+                  </a:ext>
+                </a:extLst>
+              </p:cNvPr>
+              <p:cNvSpPr/>
+              <p:nvPr/>
+            </p:nvSpPr>
+            <p:spPr>
+              <a:xfrm>
+                <a:off x="1548448" y="2145499"/>
+                <a:ext cx="276225" cy="47625"/>
+              </a:xfrm>
+              <a:custGeom>
+                <a:avLst/>
+                <a:gdLst>
+                  <a:gd name="connsiteX0" fmla="*/ 7144 w 276225"/>
+                  <a:gd name="connsiteY0" fmla="*/ 7144 h 47625"/>
+                  <a:gd name="connsiteX1" fmla="*/ 273844 w 276225"/>
+                  <a:gd name="connsiteY1" fmla="*/ 7144 h 47625"/>
+                  <a:gd name="connsiteX2" fmla="*/ 273844 w 276225"/>
+                  <a:gd name="connsiteY2" fmla="*/ 45244 h 47625"/>
+                  <a:gd name="connsiteX3" fmla="*/ 7144 w 276225"/>
+                  <a:gd name="connsiteY3" fmla="*/ 45244 h 47625"/>
+                </a:gdLst>
+                <a:ahLst/>
+                <a:cxnLst>
+                  <a:cxn ang="0">
+                    <a:pos x="connsiteX0" y="connsiteY0"/>
+                  </a:cxn>
+                  <a:cxn ang="0">
+                    <a:pos x="connsiteX1" y="connsiteY1"/>
+                  </a:cxn>
+                  <a:cxn ang="0">
+                    <a:pos x="connsiteX2" y="connsiteY2"/>
+                  </a:cxn>
+                  <a:cxn ang="0">
+                    <a:pos x="connsiteX3" y="connsiteY3"/>
+                  </a:cxn>
+                </a:cxnLst>
+                <a:rect l="l" t="t" r="r" b="b"/>
+                <a:pathLst>
+                  <a:path w="276225" h="47625">
+                    <a:moveTo>
+                      <a:pt x="7144" y="7144"/>
+                    </a:moveTo>
+                    <a:lnTo>
+                      <a:pt x="273844" y="7144"/>
+                    </a:lnTo>
+                    <a:lnTo>
+                      <a:pt x="273844" y="45244"/>
+                    </a:lnTo>
+                    <a:lnTo>
+                      <a:pt x="7144" y="45244"/>
+                    </a:lnTo>
+                    <a:close/>
+                  </a:path>
+                </a:pathLst>
+              </a:custGeom>
+              <a:solidFill>
+                <a:schemeClr val="bg1">
+                  <a:lumMod val="65000"/>
+                </a:schemeClr>
+              </a:solidFill>
+              <a:ln w="9525" cap="flat">
+                <a:noFill/>
+                <a:prstDash val="solid"/>
+                <a:miter/>
+              </a:ln>
+            </p:spPr>
+            <p:txBody>
+              <a:bodyPr rtlCol="0" anchor="ctr"/>
+              <a:lstStyle/>
+              <a:p>
+                <a:endParaRPr lang="en-US"/>
+              </a:p>
+            </p:txBody>
+          </p:sp>
+          <p:sp>
+            <p:nvSpPr>
+              <p:cNvPr id="66" name="Freeform: Shape 65">
+                <a:extLst>
+                  <a:ext uri="{FF2B5EF4-FFF2-40B4-BE49-F238E27FC236}">
+                    <a16:creationId xmlns:a16="http://schemas.microsoft.com/office/drawing/2014/main" id="{E8FEE574-C864-4189-B1E7-7617F91E77C4}"/>
+                  </a:ext>
+                </a:extLst>
+              </p:cNvPr>
+              <p:cNvSpPr/>
+              <p:nvPr/>
+            </p:nvSpPr>
+            <p:spPr>
+              <a:xfrm>
+                <a:off x="1548448" y="2219317"/>
+                <a:ext cx="276225" cy="52388"/>
+              </a:xfrm>
+              <a:custGeom>
+                <a:avLst/>
+                <a:gdLst>
+                  <a:gd name="connsiteX0" fmla="*/ 7144 w 276225"/>
+                  <a:gd name="connsiteY0" fmla="*/ 7144 h 47625"/>
+                  <a:gd name="connsiteX1" fmla="*/ 273844 w 276225"/>
+                  <a:gd name="connsiteY1" fmla="*/ 7144 h 47625"/>
+                  <a:gd name="connsiteX2" fmla="*/ 273844 w 276225"/>
+                  <a:gd name="connsiteY2" fmla="*/ 45244 h 47625"/>
+                  <a:gd name="connsiteX3" fmla="*/ 7144 w 276225"/>
+                  <a:gd name="connsiteY3" fmla="*/ 45244 h 47625"/>
+                </a:gdLst>
+                <a:ahLst/>
+                <a:cxnLst>
+                  <a:cxn ang="0">
+                    <a:pos x="connsiteX0" y="connsiteY0"/>
+                  </a:cxn>
+                  <a:cxn ang="0">
+                    <a:pos x="connsiteX1" y="connsiteY1"/>
+                  </a:cxn>
+                  <a:cxn ang="0">
+                    <a:pos x="connsiteX2" y="connsiteY2"/>
+                  </a:cxn>
+                  <a:cxn ang="0">
+                    <a:pos x="connsiteX3" y="connsiteY3"/>
+                  </a:cxn>
+                </a:cxnLst>
+                <a:rect l="l" t="t" r="r" b="b"/>
+                <a:pathLst>
+                  <a:path w="276225" h="47625">
+                    <a:moveTo>
+                      <a:pt x="7144" y="7144"/>
+                    </a:moveTo>
+                    <a:lnTo>
+                      <a:pt x="273844" y="7144"/>
+                    </a:lnTo>
+                    <a:lnTo>
+                      <a:pt x="273844" y="45244"/>
+                    </a:lnTo>
+                    <a:lnTo>
+                      <a:pt x="7144" y="45244"/>
+                    </a:lnTo>
+                    <a:close/>
+                  </a:path>
+                </a:pathLst>
+              </a:custGeom>
+              <a:solidFill>
+                <a:schemeClr val="bg1">
+                  <a:lumMod val="65000"/>
+                </a:schemeClr>
+              </a:solidFill>
+              <a:ln w="9525" cap="flat">
+                <a:noFill/>
+                <a:prstDash val="solid"/>
+                <a:miter/>
+              </a:ln>
+            </p:spPr>
+            <p:txBody>
+              <a:bodyPr rtlCol="0" anchor="ctr"/>
+              <a:lstStyle/>
+              <a:p>
+                <a:endParaRPr lang="en-US"/>
+              </a:p>
+            </p:txBody>
+          </p:sp>
+          <p:sp>
+            <p:nvSpPr>
+              <p:cNvPr id="67" name="Freeform: Shape 66">
+                <a:extLst>
+                  <a:ext uri="{FF2B5EF4-FFF2-40B4-BE49-F238E27FC236}">
+                    <a16:creationId xmlns:a16="http://schemas.microsoft.com/office/drawing/2014/main" id="{FFF3DF78-85E3-44A4-82F1-2704348321DB}"/>
+                  </a:ext>
+                </a:extLst>
+              </p:cNvPr>
+              <p:cNvSpPr/>
+              <p:nvPr/>
+            </p:nvSpPr>
+            <p:spPr>
+              <a:xfrm>
+                <a:off x="1433715" y="1690310"/>
+                <a:ext cx="771525" cy="768096"/>
+              </a:xfrm>
+              <a:custGeom>
+                <a:avLst/>
+                <a:gdLst>
+                  <a:gd name="connsiteX0" fmla="*/ 7144 w 771525"/>
+                  <a:gd name="connsiteY0" fmla="*/ 540544 h 542925"/>
+                  <a:gd name="connsiteX1" fmla="*/ 769144 w 771525"/>
+                  <a:gd name="connsiteY1" fmla="*/ 540544 h 542925"/>
+                  <a:gd name="connsiteX2" fmla="*/ 769144 w 771525"/>
+                  <a:gd name="connsiteY2" fmla="*/ 7144 h 542925"/>
+                  <a:gd name="connsiteX3" fmla="*/ 7144 w 771525"/>
+                  <a:gd name="connsiteY3" fmla="*/ 7144 h 542925"/>
+                  <a:gd name="connsiteX4" fmla="*/ 7144 w 771525"/>
+                  <a:gd name="connsiteY4" fmla="*/ 540544 h 542925"/>
+                  <a:gd name="connsiteX5" fmla="*/ 711994 w 771525"/>
+                  <a:gd name="connsiteY5" fmla="*/ 483394 h 542925"/>
+                  <a:gd name="connsiteX6" fmla="*/ 64294 w 771525"/>
+                  <a:gd name="connsiteY6" fmla="*/ 483394 h 542925"/>
+                  <a:gd name="connsiteX7" fmla="*/ 64294 w 771525"/>
+                  <a:gd name="connsiteY7" fmla="*/ 64294 h 542925"/>
+                  <a:gd name="connsiteX8" fmla="*/ 711994 w 771525"/>
+                  <a:gd name="connsiteY8" fmla="*/ 64294 h 542925"/>
+                  <a:gd name="connsiteX9" fmla="*/ 711994 w 771525"/>
+                  <a:gd name="connsiteY9" fmla="*/ 483394 h 542925"/>
+                </a:gdLst>
+                <a:ahLst/>
+                <a:cxnLst>
+                  <a:cxn ang="0">
+                    <a:pos x="connsiteX0" y="connsiteY0"/>
+                  </a:cxn>
+                  <a:cxn ang="0">
+                    <a:pos x="connsiteX1" y="connsiteY1"/>
+                  </a:cxn>
+                  <a:cxn ang="0">
+                    <a:pos x="connsiteX2" y="connsiteY2"/>
+                  </a:cxn>
+                  <a:cxn ang="0">
+                    <a:pos x="connsiteX3" y="connsiteY3"/>
+                  </a:cxn>
+                  <a:cxn ang="0">
+                    <a:pos x="connsiteX4" y="connsiteY4"/>
+                  </a:cxn>
+                  <a:cxn ang="0">
+                    <a:pos x="connsiteX5" y="connsiteY5"/>
+                  </a:cxn>
+                  <a:cxn ang="0">
+                    <a:pos x="connsiteX6" y="connsiteY6"/>
+                  </a:cxn>
+                  <a:cxn ang="0">
+                    <a:pos x="connsiteX7" y="connsiteY7"/>
+                  </a:cxn>
+                  <a:cxn ang="0">
+                    <a:pos x="connsiteX8" y="connsiteY8"/>
+                  </a:cxn>
+                  <a:cxn ang="0">
+                    <a:pos x="connsiteX9" y="connsiteY9"/>
+                  </a:cxn>
+                </a:cxnLst>
+                <a:rect l="l" t="t" r="r" b="b"/>
+                <a:pathLst>
+                  <a:path w="771525" h="542925">
+                    <a:moveTo>
+                      <a:pt x="7144" y="540544"/>
+                    </a:moveTo>
+                    <a:lnTo>
+                      <a:pt x="769144" y="540544"/>
+                    </a:lnTo>
+                    <a:lnTo>
+                      <a:pt x="769144" y="7144"/>
+                    </a:lnTo>
+                    <a:lnTo>
+                      <a:pt x="7144" y="7144"/>
+                    </a:lnTo>
+                    <a:lnTo>
+                      <a:pt x="7144" y="540544"/>
+                    </a:lnTo>
+                    <a:close/>
+                    <a:moveTo>
+                      <a:pt x="711994" y="483394"/>
+                    </a:moveTo>
+                    <a:lnTo>
+                      <a:pt x="64294" y="483394"/>
+                    </a:lnTo>
+                    <a:lnTo>
+                      <a:pt x="64294" y="64294"/>
+                    </a:lnTo>
+                    <a:lnTo>
+                      <a:pt x="711994" y="64294"/>
+                    </a:lnTo>
+                    <a:lnTo>
+                      <a:pt x="711994" y="483394"/>
+                    </a:lnTo>
+                    <a:close/>
+                  </a:path>
+                </a:pathLst>
+              </a:custGeom>
+              <a:solidFill>
+                <a:srgbClr val="F29C1F"/>
+              </a:solidFill>
+              <a:ln w="9525" cap="flat">
+                <a:noFill/>
+                <a:prstDash val="solid"/>
+                <a:miter/>
+              </a:ln>
+            </p:spPr>
+            <p:txBody>
+              <a:bodyPr rtlCol="0" anchor="ctr"/>
+              <a:lstStyle/>
+              <a:p>
+                <a:endParaRPr lang="en-US" dirty="0"/>
+              </a:p>
+            </p:txBody>
+          </p:sp>
+          <p:sp>
+            <p:nvSpPr>
+              <p:cNvPr id="68" name="Freeform: Shape 67">
+                <a:extLst>
+                  <a:ext uri="{FF2B5EF4-FFF2-40B4-BE49-F238E27FC236}">
+                    <a16:creationId xmlns:a16="http://schemas.microsoft.com/office/drawing/2014/main" id="{2995169F-C8AD-484F-ACFB-3C878C936F83}"/>
+                  </a:ext>
+                </a:extLst>
+              </p:cNvPr>
+              <p:cNvSpPr/>
+              <p:nvPr/>
+            </p:nvSpPr>
+            <p:spPr>
+              <a:xfrm>
+                <a:off x="1880237" y="2089043"/>
+                <a:ext cx="256481" cy="256481"/>
+              </a:xfrm>
+              <a:custGeom>
+                <a:avLst/>
+                <a:gdLst>
+                  <a:gd name="connsiteX0" fmla="*/ 130969 w 161925"/>
+                  <a:gd name="connsiteY0" fmla="*/ 52864 h 161925"/>
+                  <a:gd name="connsiteX1" fmla="*/ 134779 w 161925"/>
+                  <a:gd name="connsiteY1" fmla="*/ 27146 h 161925"/>
+                  <a:gd name="connsiteX2" fmla="*/ 110014 w 161925"/>
+                  <a:gd name="connsiteY2" fmla="*/ 31909 h 161925"/>
+                  <a:gd name="connsiteX3" fmla="*/ 100489 w 161925"/>
+                  <a:gd name="connsiteY3" fmla="*/ 7144 h 161925"/>
+                  <a:gd name="connsiteX4" fmla="*/ 81439 w 161925"/>
+                  <a:gd name="connsiteY4" fmla="*/ 24289 h 161925"/>
+                  <a:gd name="connsiteX5" fmla="*/ 61436 w 161925"/>
+                  <a:gd name="connsiteY5" fmla="*/ 7144 h 161925"/>
+                  <a:gd name="connsiteX6" fmla="*/ 52864 w 161925"/>
+                  <a:gd name="connsiteY6" fmla="*/ 31909 h 161925"/>
+                  <a:gd name="connsiteX7" fmla="*/ 27146 w 161925"/>
+                  <a:gd name="connsiteY7" fmla="*/ 27146 h 161925"/>
+                  <a:gd name="connsiteX8" fmla="*/ 31909 w 161925"/>
+                  <a:gd name="connsiteY8" fmla="*/ 52864 h 161925"/>
+                  <a:gd name="connsiteX9" fmla="*/ 7144 w 161925"/>
+                  <a:gd name="connsiteY9" fmla="*/ 61436 h 161925"/>
+                  <a:gd name="connsiteX10" fmla="*/ 24289 w 161925"/>
+                  <a:gd name="connsiteY10" fmla="*/ 81439 h 161925"/>
+                  <a:gd name="connsiteX11" fmla="*/ 7144 w 161925"/>
+                  <a:gd name="connsiteY11" fmla="*/ 100489 h 161925"/>
+                  <a:gd name="connsiteX12" fmla="*/ 31909 w 161925"/>
+                  <a:gd name="connsiteY12" fmla="*/ 110014 h 161925"/>
+                  <a:gd name="connsiteX13" fmla="*/ 27146 w 161925"/>
+                  <a:gd name="connsiteY13" fmla="*/ 134779 h 161925"/>
+                  <a:gd name="connsiteX14" fmla="*/ 52864 w 161925"/>
+                  <a:gd name="connsiteY14" fmla="*/ 130969 h 161925"/>
+                  <a:gd name="connsiteX15" fmla="*/ 61436 w 161925"/>
+                  <a:gd name="connsiteY15" fmla="*/ 154781 h 161925"/>
+                  <a:gd name="connsiteX16" fmla="*/ 81439 w 161925"/>
+                  <a:gd name="connsiteY16" fmla="*/ 138589 h 161925"/>
+                  <a:gd name="connsiteX17" fmla="*/ 100489 w 161925"/>
+                  <a:gd name="connsiteY17" fmla="*/ 154781 h 161925"/>
+                  <a:gd name="connsiteX18" fmla="*/ 110014 w 161925"/>
+                  <a:gd name="connsiteY18" fmla="*/ 130969 h 161925"/>
+                  <a:gd name="connsiteX19" fmla="*/ 134779 w 161925"/>
+                  <a:gd name="connsiteY19" fmla="*/ 134779 h 161925"/>
+                  <a:gd name="connsiteX20" fmla="*/ 130969 w 161925"/>
+                  <a:gd name="connsiteY20" fmla="*/ 110014 h 161925"/>
+                  <a:gd name="connsiteX21" fmla="*/ 154781 w 161925"/>
+                  <a:gd name="connsiteY21" fmla="*/ 100489 h 161925"/>
+                  <a:gd name="connsiteX22" fmla="*/ 138589 w 161925"/>
+                  <a:gd name="connsiteY22" fmla="*/ 81439 h 161925"/>
+                  <a:gd name="connsiteX23" fmla="*/ 154781 w 161925"/>
+                  <a:gd name="connsiteY23" fmla="*/ 61436 h 161925"/>
+                </a:gdLst>
+                <a:ahLst/>
+                <a:cxnLst>
+                  <a:cxn ang="0">
+                    <a:pos x="connsiteX0" y="connsiteY0"/>
+                  </a:cxn>
+                  <a:cxn ang="0">
+                    <a:pos x="connsiteX1" y="connsiteY1"/>
+                  </a:cxn>
+                  <a:cxn ang="0">
+                    <a:pos x="connsiteX2" y="connsiteY2"/>
+                  </a:cxn>
+                  <a:cxn ang="0">
+                    <a:pos x="connsiteX3" y="connsiteY3"/>
+                  </a:cxn>
+                  <a:cxn ang="0">
+                    <a:pos x="connsiteX4" y="connsiteY4"/>
+                  </a:cxn>
+                  <a:cxn ang="0">
+                    <a:pos x="connsiteX5" y="connsiteY5"/>
+                  </a:cxn>
+                  <a:cxn ang="0">
+                    <a:pos x="connsiteX6" y="connsiteY6"/>
+                  </a:cxn>
+                  <a:cxn ang="0">
+                    <a:pos x="connsiteX7" y="connsiteY7"/>
+                  </a:cxn>
+                  <a:cxn ang="0">
+                    <a:pos x="connsiteX8" y="connsiteY8"/>
+                  </a:cxn>
+                  <a:cxn ang="0">
+                    <a:pos x="connsiteX9" y="connsiteY9"/>
+                  </a:cxn>
+                  <a:cxn ang="0">
+                    <a:pos x="connsiteX10" y="connsiteY10"/>
+                  </a:cxn>
+                  <a:cxn ang="0">
+                    <a:pos x="connsiteX11" y="connsiteY11"/>
+                  </a:cxn>
+                  <a:cxn ang="0">
+                    <a:pos x="connsiteX12" y="connsiteY12"/>
+                  </a:cxn>
+                  <a:cxn ang="0">
+                    <a:pos x="connsiteX13" y="connsiteY13"/>
+                  </a:cxn>
+                  <a:cxn ang="0">
+                    <a:pos x="connsiteX14" y="connsiteY14"/>
+                  </a:cxn>
+                  <a:cxn ang="0">
+                    <a:pos x="connsiteX15" y="connsiteY15"/>
+                  </a:cxn>
+                  <a:cxn ang="0">
+                    <a:pos x="connsiteX16" y="connsiteY16"/>
+                  </a:cxn>
+                  <a:cxn ang="0">
+                    <a:pos x="connsiteX17" y="connsiteY17"/>
+                  </a:cxn>
+                  <a:cxn ang="0">
+                    <a:pos x="connsiteX18" y="connsiteY18"/>
+                  </a:cxn>
+                  <a:cxn ang="0">
+                    <a:pos x="connsiteX19" y="connsiteY19"/>
+                  </a:cxn>
+                  <a:cxn ang="0">
+                    <a:pos x="connsiteX20" y="connsiteY20"/>
+                  </a:cxn>
+                  <a:cxn ang="0">
+                    <a:pos x="connsiteX21" y="connsiteY21"/>
+                  </a:cxn>
+                  <a:cxn ang="0">
+                    <a:pos x="connsiteX22" y="connsiteY22"/>
+                  </a:cxn>
+                  <a:cxn ang="0">
+                    <a:pos x="connsiteX23" y="connsiteY23"/>
+                  </a:cxn>
+                </a:cxnLst>
+                <a:rect l="l" t="t" r="r" b="b"/>
+                <a:pathLst>
+                  <a:path w="161925" h="161925">
+                    <a:moveTo>
+                      <a:pt x="130969" y="52864"/>
+                    </a:moveTo>
+                    <a:lnTo>
+                      <a:pt x="134779" y="27146"/>
+                    </a:lnTo>
+                    <a:lnTo>
+                      <a:pt x="110014" y="31909"/>
+                    </a:lnTo>
+                    <a:lnTo>
+                      <a:pt x="100489" y="7144"/>
+                    </a:lnTo>
+                    <a:lnTo>
+                      <a:pt x="81439" y="24289"/>
+                    </a:lnTo>
+                    <a:lnTo>
+                      <a:pt x="61436" y="7144"/>
+                    </a:lnTo>
+                    <a:lnTo>
+                      <a:pt x="52864" y="31909"/>
+                    </a:lnTo>
+                    <a:lnTo>
+                      <a:pt x="27146" y="27146"/>
+                    </a:lnTo>
+                    <a:lnTo>
+                      <a:pt x="31909" y="52864"/>
+                    </a:lnTo>
+                    <a:lnTo>
+                      <a:pt x="7144" y="61436"/>
+                    </a:lnTo>
+                    <a:lnTo>
+                      <a:pt x="24289" y="81439"/>
+                    </a:lnTo>
+                    <a:lnTo>
+                      <a:pt x="7144" y="100489"/>
+                    </a:lnTo>
+                    <a:lnTo>
+                      <a:pt x="31909" y="110014"/>
+                    </a:lnTo>
+                    <a:lnTo>
+                      <a:pt x="27146" y="134779"/>
+                    </a:lnTo>
+                    <a:lnTo>
+                      <a:pt x="52864" y="130969"/>
+                    </a:lnTo>
+                    <a:lnTo>
+                      <a:pt x="61436" y="154781"/>
+                    </a:lnTo>
+                    <a:lnTo>
+                      <a:pt x="81439" y="138589"/>
+                    </a:lnTo>
+                    <a:lnTo>
+                      <a:pt x="100489" y="154781"/>
+                    </a:lnTo>
+                    <a:lnTo>
+                      <a:pt x="110014" y="130969"/>
+                    </a:lnTo>
+                    <a:lnTo>
+                      <a:pt x="134779" y="134779"/>
+                    </a:lnTo>
+                    <a:lnTo>
+                      <a:pt x="130969" y="110014"/>
+                    </a:lnTo>
+                    <a:lnTo>
+                      <a:pt x="154781" y="100489"/>
+                    </a:lnTo>
+                    <a:lnTo>
+                      <a:pt x="138589" y="81439"/>
+                    </a:lnTo>
+                    <a:lnTo>
+                      <a:pt x="154781" y="61436"/>
+                    </a:lnTo>
+                    <a:close/>
+                  </a:path>
+                </a:pathLst>
+              </a:custGeom>
+              <a:solidFill>
+                <a:schemeClr val="bg1">
+                  <a:lumMod val="50000"/>
+                </a:schemeClr>
+              </a:solidFill>
+              <a:ln w="9525" cap="flat">
+                <a:noFill/>
+                <a:prstDash val="solid"/>
+                <a:miter/>
+              </a:ln>
+            </p:spPr>
+            <p:txBody>
+              <a:bodyPr rtlCol="0" anchor="ctr"/>
+              <a:lstStyle/>
+              <a:p>
+                <a:endParaRPr lang="en-US"/>
+              </a:p>
+            </p:txBody>
+          </p:sp>
+          <p:sp>
+            <p:nvSpPr>
+              <p:cNvPr id="69" name="Freeform: Shape 68">
+                <a:extLst>
+                  <a:ext uri="{FF2B5EF4-FFF2-40B4-BE49-F238E27FC236}">
+                    <a16:creationId xmlns:a16="http://schemas.microsoft.com/office/drawing/2014/main" id="{724E0259-EF69-466A-8F2F-848847AE391D}"/>
+                  </a:ext>
+                </a:extLst>
+              </p:cNvPr>
+              <p:cNvSpPr/>
+              <p:nvPr/>
+            </p:nvSpPr>
+            <p:spPr>
+              <a:xfrm>
+                <a:off x="1548446" y="2297899"/>
+                <a:ext cx="276225" cy="47625"/>
+              </a:xfrm>
+              <a:custGeom>
+                <a:avLst/>
+                <a:gdLst>
+                  <a:gd name="connsiteX0" fmla="*/ 7144 w 276225"/>
+                  <a:gd name="connsiteY0" fmla="*/ 7144 h 47625"/>
+                  <a:gd name="connsiteX1" fmla="*/ 273844 w 276225"/>
+                  <a:gd name="connsiteY1" fmla="*/ 7144 h 47625"/>
+                  <a:gd name="connsiteX2" fmla="*/ 273844 w 276225"/>
+                  <a:gd name="connsiteY2" fmla="*/ 45244 h 47625"/>
+                  <a:gd name="connsiteX3" fmla="*/ 7144 w 276225"/>
+                  <a:gd name="connsiteY3" fmla="*/ 45244 h 47625"/>
+                </a:gdLst>
+                <a:ahLst/>
+                <a:cxnLst>
+                  <a:cxn ang="0">
+                    <a:pos x="connsiteX0" y="connsiteY0"/>
+                  </a:cxn>
+                  <a:cxn ang="0">
+                    <a:pos x="connsiteX1" y="connsiteY1"/>
+                  </a:cxn>
+                  <a:cxn ang="0">
+                    <a:pos x="connsiteX2" y="connsiteY2"/>
+                  </a:cxn>
+                  <a:cxn ang="0">
+                    <a:pos x="connsiteX3" y="connsiteY3"/>
+                  </a:cxn>
+                </a:cxnLst>
+                <a:rect l="l" t="t" r="r" b="b"/>
+                <a:pathLst>
+                  <a:path w="276225" h="47625">
+                    <a:moveTo>
+                      <a:pt x="7144" y="7144"/>
+                    </a:moveTo>
+                    <a:lnTo>
+                      <a:pt x="273844" y="7144"/>
+                    </a:lnTo>
+                    <a:lnTo>
+                      <a:pt x="273844" y="45244"/>
+                    </a:lnTo>
+                    <a:lnTo>
+                      <a:pt x="7144" y="45244"/>
+                    </a:lnTo>
+                    <a:close/>
+                  </a:path>
+                </a:pathLst>
+              </a:custGeom>
+              <a:solidFill>
+                <a:schemeClr val="bg1">
+                  <a:lumMod val="65000"/>
+                </a:schemeClr>
+              </a:solidFill>
+              <a:ln w="9525" cap="flat">
+                <a:noFill/>
+                <a:prstDash val="solid"/>
+                <a:miter/>
+              </a:ln>
+            </p:spPr>
+            <p:txBody>
+              <a:bodyPr rtlCol="0" anchor="ctr"/>
+              <a:lstStyle/>
+              <a:p>
+                <a:endParaRPr lang="en-US"/>
+              </a:p>
+            </p:txBody>
+          </p:sp>
+        </p:grpSp>
+        <p:pic>
+          <p:nvPicPr>
+            <p:cNvPr id="78" name="Graphic 77" descr="Close">
+              <a:extLst>
+                <a:ext uri="{FF2B5EF4-FFF2-40B4-BE49-F238E27FC236}">
+                  <a16:creationId xmlns:a16="http://schemas.microsoft.com/office/drawing/2014/main" id="{2060C32E-6108-4F5F-9362-6F85A9272FE2}"/>
+                </a:ext>
+              </a:extLst>
+            </p:cNvPr>
+            <p:cNvPicPr>
+              <a:picLocks noChangeAspect="1"/>
+            </p:cNvPicPr>
+            <p:nvPr/>
+          </p:nvPicPr>
+          <p:blipFill>
+            <a:blip r:embed="rId2">
+              <a:extLst>
+                <a:ext uri="{28A0092B-C50C-407E-A947-70E740481C1C}">
+                  <a14:useLocalDpi xmlns:a14="http://schemas.microsoft.com/office/drawing/2010/main" val="0"/>
+                </a:ext>
+                <a:ext uri="{96DAC541-7B7A-43D3-8B79-37D633B846F1}">
+                  <asvg:svgBlip xmlns:asvg="http://schemas.microsoft.com/office/drawing/2016/SVG/main" r:embed="rId3"/>
+                </a:ext>
+              </a:extLst>
+            </a:blip>
+            <a:stretch>
+              <a:fillRect/>
+            </a:stretch>
+          </p:blipFill>
+          <p:spPr>
+            <a:xfrm>
+              <a:off x="8800287" y="4336688"/>
+              <a:ext cx="300038" cy="300038"/>
+            </a:xfrm>
+            <a:prstGeom prst="rect">
+              <a:avLst/>
+            </a:prstGeom>
+            <a:effectLst/>
+          </p:spPr>
+        </p:pic>
+      </p:grpSp>
+      <p:grpSp>
+        <p:nvGrpSpPr>
+          <p:cNvPr id="3" name="Group 2">
+            <a:extLst>
+              <a:ext uri="{FF2B5EF4-FFF2-40B4-BE49-F238E27FC236}">
+                <a16:creationId xmlns:a16="http://schemas.microsoft.com/office/drawing/2014/main" id="{C7D19386-A1FE-4347-8666-5209FEAFF0B2}"/>
+              </a:ext>
+            </a:extLst>
+          </p:cNvPr>
+          <p:cNvGrpSpPr/>
+          <p:nvPr/>
+        </p:nvGrpSpPr>
+        <p:grpSpPr>
+          <a:xfrm>
+            <a:off x="8325581" y="2655149"/>
+            <a:ext cx="771525" cy="768096"/>
+            <a:chOff x="8325581" y="2655149"/>
+            <a:chExt cx="771525" cy="768096"/>
+          </a:xfrm>
+        </p:grpSpPr>
+        <p:grpSp>
+          <p:nvGrpSpPr>
+            <p:cNvPr id="70" name="Group 69">
+              <a:extLst>
+                <a:ext uri="{FF2B5EF4-FFF2-40B4-BE49-F238E27FC236}">
+                  <a16:creationId xmlns:a16="http://schemas.microsoft.com/office/drawing/2014/main" id="{256916AD-BC4F-44CD-ACE5-B029C21E2E1F}"/>
+                </a:ext>
+              </a:extLst>
+            </p:cNvPr>
+            <p:cNvGrpSpPr/>
+            <p:nvPr/>
+          </p:nvGrpSpPr>
+          <p:grpSpPr>
+            <a:xfrm>
+              <a:off x="8325581" y="2655149"/>
+              <a:ext cx="771525" cy="768096"/>
+              <a:chOff x="1433715" y="1690310"/>
+              <a:chExt cx="771525" cy="768096"/>
+            </a:xfrm>
+          </p:grpSpPr>
+          <p:sp>
+            <p:nvSpPr>
+              <p:cNvPr id="71" name="TextBox 70">
+                <a:extLst>
+                  <a:ext uri="{FF2B5EF4-FFF2-40B4-BE49-F238E27FC236}">
+                    <a16:creationId xmlns:a16="http://schemas.microsoft.com/office/drawing/2014/main" id="{0099325E-8277-4C8B-91C5-A56778A37A56}"/>
+                  </a:ext>
+                </a:extLst>
+              </p:cNvPr>
+              <p:cNvSpPr txBox="1"/>
+              <p:nvPr/>
+            </p:nvSpPr>
+            <p:spPr>
+              <a:xfrm>
+                <a:off x="1467365" y="1819896"/>
+                <a:ext cx="704224" cy="400110"/>
+              </a:xfrm>
+              <a:prstGeom prst="rect">
+                <a:avLst/>
+              </a:prstGeom>
+              <a:noFill/>
+            </p:spPr>
+            <p:txBody>
+              <a:bodyPr wrap="square" rtlCol="0">
+                <a:spAutoFit/>
+              </a:bodyPr>
+              <a:lstStyle/>
+              <a:p>
+                <a:r>
+                  <a:rPr lang="en-US" sz="2000" b="1" dirty="0">
+                    <a:latin typeface="Sans Serif Collection" panose="020B0502040504020204" pitchFamily="34" charset="0"/>
+                    <a:ea typeface="Sans Serif Collection" panose="020B0502040504020204" pitchFamily="34" charset="0"/>
+                    <a:cs typeface="Sans Serif Collection" panose="020B0502040504020204" pitchFamily="34" charset="0"/>
+                  </a:rPr>
+                  <a:t>CVC</a:t>
+                </a:r>
+                <a:endParaRPr lang="en-US" sz="2800" b="1" dirty="0">
+                  <a:latin typeface="Sans Serif Collection" panose="020B0502040504020204" pitchFamily="34" charset="0"/>
+                  <a:ea typeface="Sans Serif Collection" panose="020B0502040504020204" pitchFamily="34" charset="0"/>
+                  <a:cs typeface="Sans Serif Collection" panose="020B0502040504020204" pitchFamily="34" charset="0"/>
+                </a:endParaRPr>
+              </a:p>
+            </p:txBody>
+          </p:sp>
+          <p:sp>
+            <p:nvSpPr>
+              <p:cNvPr id="72" name="Freeform: Shape 71">
+                <a:extLst>
+                  <a:ext uri="{FF2B5EF4-FFF2-40B4-BE49-F238E27FC236}">
+                    <a16:creationId xmlns:a16="http://schemas.microsoft.com/office/drawing/2014/main" id="{AE50A901-9B1B-4510-B951-F4F3E51A7D11}"/>
+                  </a:ext>
+                </a:extLst>
+              </p:cNvPr>
+              <p:cNvSpPr/>
+              <p:nvPr/>
+            </p:nvSpPr>
+            <p:spPr>
+              <a:xfrm>
+                <a:off x="1548448" y="2145499"/>
+                <a:ext cx="276225" cy="47625"/>
+              </a:xfrm>
+              <a:custGeom>
+                <a:avLst/>
+                <a:gdLst>
+                  <a:gd name="connsiteX0" fmla="*/ 7144 w 276225"/>
+                  <a:gd name="connsiteY0" fmla="*/ 7144 h 47625"/>
+                  <a:gd name="connsiteX1" fmla="*/ 273844 w 276225"/>
+                  <a:gd name="connsiteY1" fmla="*/ 7144 h 47625"/>
+                  <a:gd name="connsiteX2" fmla="*/ 273844 w 276225"/>
+                  <a:gd name="connsiteY2" fmla="*/ 45244 h 47625"/>
+                  <a:gd name="connsiteX3" fmla="*/ 7144 w 276225"/>
+                  <a:gd name="connsiteY3" fmla="*/ 45244 h 47625"/>
+                </a:gdLst>
+                <a:ahLst/>
+                <a:cxnLst>
+                  <a:cxn ang="0">
+                    <a:pos x="connsiteX0" y="connsiteY0"/>
+                  </a:cxn>
+                  <a:cxn ang="0">
+                    <a:pos x="connsiteX1" y="connsiteY1"/>
+                  </a:cxn>
+                  <a:cxn ang="0">
+                    <a:pos x="connsiteX2" y="connsiteY2"/>
+                  </a:cxn>
+                  <a:cxn ang="0">
+                    <a:pos x="connsiteX3" y="connsiteY3"/>
+                  </a:cxn>
+                </a:cxnLst>
+                <a:rect l="l" t="t" r="r" b="b"/>
+                <a:pathLst>
+                  <a:path w="276225" h="47625">
+                    <a:moveTo>
+                      <a:pt x="7144" y="7144"/>
+                    </a:moveTo>
+                    <a:lnTo>
+                      <a:pt x="273844" y="7144"/>
+                    </a:lnTo>
+                    <a:lnTo>
+                      <a:pt x="273844" y="45244"/>
+                    </a:lnTo>
+                    <a:lnTo>
+                      <a:pt x="7144" y="45244"/>
+                    </a:lnTo>
+                    <a:close/>
+                  </a:path>
+                </a:pathLst>
+              </a:custGeom>
+              <a:solidFill>
+                <a:schemeClr val="bg1">
+                  <a:lumMod val="65000"/>
+                </a:schemeClr>
+              </a:solidFill>
+              <a:ln w="9525" cap="flat">
+                <a:noFill/>
+                <a:prstDash val="solid"/>
+                <a:miter/>
+              </a:ln>
+            </p:spPr>
+            <p:txBody>
+              <a:bodyPr rtlCol="0" anchor="ctr"/>
+              <a:lstStyle/>
+              <a:p>
+                <a:endParaRPr lang="en-US"/>
+              </a:p>
+            </p:txBody>
+          </p:sp>
+          <p:sp>
+            <p:nvSpPr>
+              <p:cNvPr id="73" name="Freeform: Shape 72">
+                <a:extLst>
+                  <a:ext uri="{FF2B5EF4-FFF2-40B4-BE49-F238E27FC236}">
+                    <a16:creationId xmlns:a16="http://schemas.microsoft.com/office/drawing/2014/main" id="{80E52EF5-3F14-43C3-B224-1F7573378AD2}"/>
+                  </a:ext>
+                </a:extLst>
+              </p:cNvPr>
+              <p:cNvSpPr/>
+              <p:nvPr/>
+            </p:nvSpPr>
+            <p:spPr>
+              <a:xfrm>
+                <a:off x="1548448" y="2219317"/>
+                <a:ext cx="276225" cy="52388"/>
+              </a:xfrm>
+              <a:custGeom>
+                <a:avLst/>
+                <a:gdLst>
+                  <a:gd name="connsiteX0" fmla="*/ 7144 w 276225"/>
+                  <a:gd name="connsiteY0" fmla="*/ 7144 h 47625"/>
+                  <a:gd name="connsiteX1" fmla="*/ 273844 w 276225"/>
+                  <a:gd name="connsiteY1" fmla="*/ 7144 h 47625"/>
+                  <a:gd name="connsiteX2" fmla="*/ 273844 w 276225"/>
+                  <a:gd name="connsiteY2" fmla="*/ 45244 h 47625"/>
+                  <a:gd name="connsiteX3" fmla="*/ 7144 w 276225"/>
+                  <a:gd name="connsiteY3" fmla="*/ 45244 h 47625"/>
+                </a:gdLst>
+                <a:ahLst/>
+                <a:cxnLst>
+                  <a:cxn ang="0">
+                    <a:pos x="connsiteX0" y="connsiteY0"/>
+                  </a:cxn>
+                  <a:cxn ang="0">
+                    <a:pos x="connsiteX1" y="connsiteY1"/>
+                  </a:cxn>
+                  <a:cxn ang="0">
+                    <a:pos x="connsiteX2" y="connsiteY2"/>
+                  </a:cxn>
+                  <a:cxn ang="0">
+                    <a:pos x="connsiteX3" y="connsiteY3"/>
+                  </a:cxn>
+                </a:cxnLst>
+                <a:rect l="l" t="t" r="r" b="b"/>
+                <a:pathLst>
+                  <a:path w="276225" h="47625">
+                    <a:moveTo>
+                      <a:pt x="7144" y="7144"/>
+                    </a:moveTo>
+                    <a:lnTo>
+                      <a:pt x="273844" y="7144"/>
+                    </a:lnTo>
+                    <a:lnTo>
+                      <a:pt x="273844" y="45244"/>
+                    </a:lnTo>
+                    <a:lnTo>
+                      <a:pt x="7144" y="45244"/>
+                    </a:lnTo>
+                    <a:close/>
+                  </a:path>
+                </a:pathLst>
+              </a:custGeom>
+              <a:solidFill>
+                <a:schemeClr val="bg1">
+                  <a:lumMod val="65000"/>
+                </a:schemeClr>
+              </a:solidFill>
+              <a:ln w="9525" cap="flat">
+                <a:noFill/>
+                <a:prstDash val="solid"/>
+                <a:miter/>
+              </a:ln>
+            </p:spPr>
+            <p:txBody>
+              <a:bodyPr rtlCol="0" anchor="ctr"/>
+              <a:lstStyle/>
+              <a:p>
+                <a:endParaRPr lang="en-US"/>
+              </a:p>
+            </p:txBody>
+          </p:sp>
+          <p:sp>
+            <p:nvSpPr>
+              <p:cNvPr id="74" name="Freeform: Shape 73">
+                <a:extLst>
+                  <a:ext uri="{FF2B5EF4-FFF2-40B4-BE49-F238E27FC236}">
+                    <a16:creationId xmlns:a16="http://schemas.microsoft.com/office/drawing/2014/main" id="{87EFDE97-D8E6-49A6-B088-E0EE0E291D03}"/>
+                  </a:ext>
+                </a:extLst>
+              </p:cNvPr>
+              <p:cNvSpPr/>
+              <p:nvPr/>
+            </p:nvSpPr>
+            <p:spPr>
+              <a:xfrm>
+                <a:off x="1433715" y="1690310"/>
+                <a:ext cx="771525" cy="768096"/>
+              </a:xfrm>
+              <a:custGeom>
+                <a:avLst/>
+                <a:gdLst>
+                  <a:gd name="connsiteX0" fmla="*/ 7144 w 771525"/>
+                  <a:gd name="connsiteY0" fmla="*/ 540544 h 542925"/>
+                  <a:gd name="connsiteX1" fmla="*/ 769144 w 771525"/>
+                  <a:gd name="connsiteY1" fmla="*/ 540544 h 542925"/>
+                  <a:gd name="connsiteX2" fmla="*/ 769144 w 771525"/>
+                  <a:gd name="connsiteY2" fmla="*/ 7144 h 542925"/>
+                  <a:gd name="connsiteX3" fmla="*/ 7144 w 771525"/>
+                  <a:gd name="connsiteY3" fmla="*/ 7144 h 542925"/>
+                  <a:gd name="connsiteX4" fmla="*/ 7144 w 771525"/>
+                  <a:gd name="connsiteY4" fmla="*/ 540544 h 542925"/>
+                  <a:gd name="connsiteX5" fmla="*/ 711994 w 771525"/>
+                  <a:gd name="connsiteY5" fmla="*/ 483394 h 542925"/>
+                  <a:gd name="connsiteX6" fmla="*/ 64294 w 771525"/>
+                  <a:gd name="connsiteY6" fmla="*/ 483394 h 542925"/>
+                  <a:gd name="connsiteX7" fmla="*/ 64294 w 771525"/>
+                  <a:gd name="connsiteY7" fmla="*/ 64294 h 542925"/>
+                  <a:gd name="connsiteX8" fmla="*/ 711994 w 771525"/>
+                  <a:gd name="connsiteY8" fmla="*/ 64294 h 542925"/>
+                  <a:gd name="connsiteX9" fmla="*/ 711994 w 771525"/>
+                  <a:gd name="connsiteY9" fmla="*/ 483394 h 542925"/>
+                </a:gdLst>
+                <a:ahLst/>
+                <a:cxnLst>
+                  <a:cxn ang="0">
+                    <a:pos x="connsiteX0" y="connsiteY0"/>
+                  </a:cxn>
+                  <a:cxn ang="0">
+                    <a:pos x="connsiteX1" y="connsiteY1"/>
+                  </a:cxn>
+                  <a:cxn ang="0">
+                    <a:pos x="connsiteX2" y="connsiteY2"/>
+                  </a:cxn>
+                  <a:cxn ang="0">
+                    <a:pos x="connsiteX3" y="connsiteY3"/>
+                  </a:cxn>
+                  <a:cxn ang="0">
+                    <a:pos x="connsiteX4" y="connsiteY4"/>
+                  </a:cxn>
+                  <a:cxn ang="0">
+                    <a:pos x="connsiteX5" y="connsiteY5"/>
+                  </a:cxn>
+                  <a:cxn ang="0">
+                    <a:pos x="connsiteX6" y="connsiteY6"/>
+                  </a:cxn>
+                  <a:cxn ang="0">
+                    <a:pos x="connsiteX7" y="connsiteY7"/>
+                  </a:cxn>
+                  <a:cxn ang="0">
+                    <a:pos x="connsiteX8" y="connsiteY8"/>
+                  </a:cxn>
+                  <a:cxn ang="0">
+                    <a:pos x="connsiteX9" y="connsiteY9"/>
+                  </a:cxn>
+                </a:cxnLst>
+                <a:rect l="l" t="t" r="r" b="b"/>
+                <a:pathLst>
+                  <a:path w="771525" h="542925">
+                    <a:moveTo>
+                      <a:pt x="7144" y="540544"/>
+                    </a:moveTo>
+                    <a:lnTo>
+                      <a:pt x="769144" y="540544"/>
+                    </a:lnTo>
+                    <a:lnTo>
+                      <a:pt x="769144" y="7144"/>
+                    </a:lnTo>
+                    <a:lnTo>
+                      <a:pt x="7144" y="7144"/>
+                    </a:lnTo>
+                    <a:lnTo>
+                      <a:pt x="7144" y="540544"/>
+                    </a:lnTo>
+                    <a:close/>
+                    <a:moveTo>
+                      <a:pt x="711994" y="483394"/>
+                    </a:moveTo>
+                    <a:lnTo>
+                      <a:pt x="64294" y="483394"/>
+                    </a:lnTo>
+                    <a:lnTo>
+                      <a:pt x="64294" y="64294"/>
+                    </a:lnTo>
+                    <a:lnTo>
+                      <a:pt x="711994" y="64294"/>
+                    </a:lnTo>
+                    <a:lnTo>
+                      <a:pt x="711994" y="483394"/>
+                    </a:lnTo>
+                    <a:close/>
+                  </a:path>
+                </a:pathLst>
+              </a:custGeom>
+              <a:solidFill>
+                <a:srgbClr val="F29C1F"/>
+              </a:solidFill>
+              <a:ln w="9525" cap="flat">
+                <a:noFill/>
+                <a:prstDash val="solid"/>
+                <a:miter/>
+              </a:ln>
+            </p:spPr>
+            <p:txBody>
+              <a:bodyPr rtlCol="0" anchor="ctr"/>
+              <a:lstStyle/>
+              <a:p>
+                <a:endParaRPr lang="en-US" dirty="0"/>
+              </a:p>
+            </p:txBody>
+          </p:sp>
+          <p:sp>
+            <p:nvSpPr>
+              <p:cNvPr id="75" name="Freeform: Shape 74">
+                <a:extLst>
+                  <a:ext uri="{FF2B5EF4-FFF2-40B4-BE49-F238E27FC236}">
+                    <a16:creationId xmlns:a16="http://schemas.microsoft.com/office/drawing/2014/main" id="{99BDEE66-E8D0-4D48-A1CE-885CFA66D956}"/>
+                  </a:ext>
+                </a:extLst>
+              </p:cNvPr>
+              <p:cNvSpPr/>
+              <p:nvPr/>
+            </p:nvSpPr>
+            <p:spPr>
+              <a:xfrm>
+                <a:off x="1880237" y="2089043"/>
+                <a:ext cx="256481" cy="256481"/>
+              </a:xfrm>
+              <a:custGeom>
+                <a:avLst/>
+                <a:gdLst>
+                  <a:gd name="connsiteX0" fmla="*/ 130969 w 161925"/>
+                  <a:gd name="connsiteY0" fmla="*/ 52864 h 161925"/>
+                  <a:gd name="connsiteX1" fmla="*/ 134779 w 161925"/>
+                  <a:gd name="connsiteY1" fmla="*/ 27146 h 161925"/>
+                  <a:gd name="connsiteX2" fmla="*/ 110014 w 161925"/>
+                  <a:gd name="connsiteY2" fmla="*/ 31909 h 161925"/>
+                  <a:gd name="connsiteX3" fmla="*/ 100489 w 161925"/>
+                  <a:gd name="connsiteY3" fmla="*/ 7144 h 161925"/>
+                  <a:gd name="connsiteX4" fmla="*/ 81439 w 161925"/>
+                  <a:gd name="connsiteY4" fmla="*/ 24289 h 161925"/>
+                  <a:gd name="connsiteX5" fmla="*/ 61436 w 161925"/>
+                  <a:gd name="connsiteY5" fmla="*/ 7144 h 161925"/>
+                  <a:gd name="connsiteX6" fmla="*/ 52864 w 161925"/>
+                  <a:gd name="connsiteY6" fmla="*/ 31909 h 161925"/>
+                  <a:gd name="connsiteX7" fmla="*/ 27146 w 161925"/>
+                  <a:gd name="connsiteY7" fmla="*/ 27146 h 161925"/>
+                  <a:gd name="connsiteX8" fmla="*/ 31909 w 161925"/>
+                  <a:gd name="connsiteY8" fmla="*/ 52864 h 161925"/>
+                  <a:gd name="connsiteX9" fmla="*/ 7144 w 161925"/>
+                  <a:gd name="connsiteY9" fmla="*/ 61436 h 161925"/>
+                  <a:gd name="connsiteX10" fmla="*/ 24289 w 161925"/>
+                  <a:gd name="connsiteY10" fmla="*/ 81439 h 161925"/>
+                  <a:gd name="connsiteX11" fmla="*/ 7144 w 161925"/>
+                  <a:gd name="connsiteY11" fmla="*/ 100489 h 161925"/>
+                  <a:gd name="connsiteX12" fmla="*/ 31909 w 161925"/>
+                  <a:gd name="connsiteY12" fmla="*/ 110014 h 161925"/>
+                  <a:gd name="connsiteX13" fmla="*/ 27146 w 161925"/>
+                  <a:gd name="connsiteY13" fmla="*/ 134779 h 161925"/>
+                  <a:gd name="connsiteX14" fmla="*/ 52864 w 161925"/>
+                  <a:gd name="connsiteY14" fmla="*/ 130969 h 161925"/>
+                  <a:gd name="connsiteX15" fmla="*/ 61436 w 161925"/>
+                  <a:gd name="connsiteY15" fmla="*/ 154781 h 161925"/>
+                  <a:gd name="connsiteX16" fmla="*/ 81439 w 161925"/>
+                  <a:gd name="connsiteY16" fmla="*/ 138589 h 161925"/>
+                  <a:gd name="connsiteX17" fmla="*/ 100489 w 161925"/>
+                  <a:gd name="connsiteY17" fmla="*/ 154781 h 161925"/>
+                  <a:gd name="connsiteX18" fmla="*/ 110014 w 161925"/>
+                  <a:gd name="connsiteY18" fmla="*/ 130969 h 161925"/>
+                  <a:gd name="connsiteX19" fmla="*/ 134779 w 161925"/>
+                  <a:gd name="connsiteY19" fmla="*/ 134779 h 161925"/>
+                  <a:gd name="connsiteX20" fmla="*/ 130969 w 161925"/>
+                  <a:gd name="connsiteY20" fmla="*/ 110014 h 161925"/>
+                  <a:gd name="connsiteX21" fmla="*/ 154781 w 161925"/>
+                  <a:gd name="connsiteY21" fmla="*/ 100489 h 161925"/>
+                  <a:gd name="connsiteX22" fmla="*/ 138589 w 161925"/>
+                  <a:gd name="connsiteY22" fmla="*/ 81439 h 161925"/>
+                  <a:gd name="connsiteX23" fmla="*/ 154781 w 161925"/>
+                  <a:gd name="connsiteY23" fmla="*/ 61436 h 161925"/>
+                </a:gdLst>
+                <a:ahLst/>
+                <a:cxnLst>
+                  <a:cxn ang="0">
+                    <a:pos x="connsiteX0" y="connsiteY0"/>
+                  </a:cxn>
+                  <a:cxn ang="0">
+                    <a:pos x="connsiteX1" y="connsiteY1"/>
+                  </a:cxn>
+                  <a:cxn ang="0">
+                    <a:pos x="connsiteX2" y="connsiteY2"/>
+                  </a:cxn>
+                  <a:cxn ang="0">
+                    <a:pos x="connsiteX3" y="connsiteY3"/>
+                  </a:cxn>
+                  <a:cxn ang="0">
+                    <a:pos x="connsiteX4" y="connsiteY4"/>
+                  </a:cxn>
+                  <a:cxn ang="0">
+                    <a:pos x="connsiteX5" y="connsiteY5"/>
+                  </a:cxn>
+                  <a:cxn ang="0">
+                    <a:pos x="connsiteX6" y="connsiteY6"/>
+                  </a:cxn>
+                  <a:cxn ang="0">
+                    <a:pos x="connsiteX7" y="connsiteY7"/>
+                  </a:cxn>
+                  <a:cxn ang="0">
+                    <a:pos x="connsiteX8" y="connsiteY8"/>
+                  </a:cxn>
+                  <a:cxn ang="0">
+                    <a:pos x="connsiteX9" y="connsiteY9"/>
+                  </a:cxn>
+                  <a:cxn ang="0">
+                    <a:pos x="connsiteX10" y="connsiteY10"/>
+                  </a:cxn>
+                  <a:cxn ang="0">
+                    <a:pos x="connsiteX11" y="connsiteY11"/>
+                  </a:cxn>
+                  <a:cxn ang="0">
+                    <a:pos x="connsiteX12" y="connsiteY12"/>
+                  </a:cxn>
+                  <a:cxn ang="0">
+                    <a:pos x="connsiteX13" y="connsiteY13"/>
+                  </a:cxn>
+                  <a:cxn ang="0">
+                    <a:pos x="connsiteX14" y="connsiteY14"/>
+                  </a:cxn>
+                  <a:cxn ang="0">
+                    <a:pos x="connsiteX15" y="connsiteY15"/>
+                  </a:cxn>
+                  <a:cxn ang="0">
+                    <a:pos x="connsiteX16" y="connsiteY16"/>
+                  </a:cxn>
+                  <a:cxn ang="0">
+                    <a:pos x="connsiteX17" y="connsiteY17"/>
+                  </a:cxn>
+                  <a:cxn ang="0">
+                    <a:pos x="connsiteX18" y="connsiteY18"/>
+                  </a:cxn>
+                  <a:cxn ang="0">
+                    <a:pos x="connsiteX19" y="connsiteY19"/>
+                  </a:cxn>
+                  <a:cxn ang="0">
+                    <a:pos x="connsiteX20" y="connsiteY20"/>
+                  </a:cxn>
+                  <a:cxn ang="0">
+                    <a:pos x="connsiteX21" y="connsiteY21"/>
+                  </a:cxn>
+                  <a:cxn ang="0">
+                    <a:pos x="connsiteX22" y="connsiteY22"/>
+                  </a:cxn>
+                  <a:cxn ang="0">
+                    <a:pos x="connsiteX23" y="connsiteY23"/>
+                  </a:cxn>
+                </a:cxnLst>
+                <a:rect l="l" t="t" r="r" b="b"/>
+                <a:pathLst>
+                  <a:path w="161925" h="161925">
+                    <a:moveTo>
+                      <a:pt x="130969" y="52864"/>
+                    </a:moveTo>
+                    <a:lnTo>
+                      <a:pt x="134779" y="27146"/>
+                    </a:lnTo>
+                    <a:lnTo>
+                      <a:pt x="110014" y="31909"/>
+                    </a:lnTo>
+                    <a:lnTo>
+                      <a:pt x="100489" y="7144"/>
+                    </a:lnTo>
+                    <a:lnTo>
+                      <a:pt x="81439" y="24289"/>
+                    </a:lnTo>
+                    <a:lnTo>
+                      <a:pt x="61436" y="7144"/>
+                    </a:lnTo>
+                    <a:lnTo>
+                      <a:pt x="52864" y="31909"/>
+                    </a:lnTo>
+                    <a:lnTo>
+                      <a:pt x="27146" y="27146"/>
+                    </a:lnTo>
+                    <a:lnTo>
+                      <a:pt x="31909" y="52864"/>
+                    </a:lnTo>
+                    <a:lnTo>
+                      <a:pt x="7144" y="61436"/>
+                    </a:lnTo>
+                    <a:lnTo>
+                      <a:pt x="24289" y="81439"/>
+                    </a:lnTo>
+                    <a:lnTo>
+                      <a:pt x="7144" y="100489"/>
+                    </a:lnTo>
+                    <a:lnTo>
+                      <a:pt x="31909" y="110014"/>
+                    </a:lnTo>
+                    <a:lnTo>
+                      <a:pt x="27146" y="134779"/>
+                    </a:lnTo>
+                    <a:lnTo>
+                      <a:pt x="52864" y="130969"/>
+                    </a:lnTo>
+                    <a:lnTo>
+                      <a:pt x="61436" y="154781"/>
+                    </a:lnTo>
+                    <a:lnTo>
+                      <a:pt x="81439" y="138589"/>
+                    </a:lnTo>
+                    <a:lnTo>
+                      <a:pt x="100489" y="154781"/>
+                    </a:lnTo>
+                    <a:lnTo>
+                      <a:pt x="110014" y="130969"/>
+                    </a:lnTo>
+                    <a:lnTo>
+                      <a:pt x="134779" y="134779"/>
+                    </a:lnTo>
+                    <a:lnTo>
+                      <a:pt x="130969" y="110014"/>
+                    </a:lnTo>
+                    <a:lnTo>
+                      <a:pt x="154781" y="100489"/>
+                    </a:lnTo>
+                    <a:lnTo>
+                      <a:pt x="138589" y="81439"/>
+                    </a:lnTo>
+                    <a:lnTo>
+                      <a:pt x="154781" y="61436"/>
+                    </a:lnTo>
+                    <a:close/>
+                  </a:path>
+                </a:pathLst>
+              </a:custGeom>
+              <a:solidFill>
+                <a:srgbClr val="FF5364"/>
+              </a:solidFill>
+              <a:ln w="9525" cap="flat">
+                <a:noFill/>
+                <a:prstDash val="solid"/>
+                <a:miter/>
+              </a:ln>
+            </p:spPr>
+            <p:txBody>
+              <a:bodyPr rtlCol="0" anchor="ctr"/>
+              <a:lstStyle/>
+              <a:p>
+                <a:endParaRPr lang="en-US"/>
+              </a:p>
+            </p:txBody>
+          </p:sp>
+          <p:sp>
+            <p:nvSpPr>
+              <p:cNvPr id="76" name="Freeform: Shape 75">
+                <a:extLst>
+                  <a:ext uri="{FF2B5EF4-FFF2-40B4-BE49-F238E27FC236}">
+                    <a16:creationId xmlns:a16="http://schemas.microsoft.com/office/drawing/2014/main" id="{AE3E63DC-8486-41B9-B92D-CE7B88877263}"/>
+                  </a:ext>
+                </a:extLst>
+              </p:cNvPr>
+              <p:cNvSpPr/>
+              <p:nvPr/>
+            </p:nvSpPr>
+            <p:spPr>
+              <a:xfrm>
+                <a:off x="1548446" y="2297899"/>
+                <a:ext cx="276225" cy="47625"/>
+              </a:xfrm>
+              <a:custGeom>
+                <a:avLst/>
+                <a:gdLst>
+                  <a:gd name="connsiteX0" fmla="*/ 7144 w 276225"/>
+                  <a:gd name="connsiteY0" fmla="*/ 7144 h 47625"/>
+                  <a:gd name="connsiteX1" fmla="*/ 273844 w 276225"/>
+                  <a:gd name="connsiteY1" fmla="*/ 7144 h 47625"/>
+                  <a:gd name="connsiteX2" fmla="*/ 273844 w 276225"/>
+                  <a:gd name="connsiteY2" fmla="*/ 45244 h 47625"/>
+                  <a:gd name="connsiteX3" fmla="*/ 7144 w 276225"/>
+                  <a:gd name="connsiteY3" fmla="*/ 45244 h 47625"/>
+                </a:gdLst>
+                <a:ahLst/>
+                <a:cxnLst>
+                  <a:cxn ang="0">
+                    <a:pos x="connsiteX0" y="connsiteY0"/>
+                  </a:cxn>
+                  <a:cxn ang="0">
+                    <a:pos x="connsiteX1" y="connsiteY1"/>
+                  </a:cxn>
+                  <a:cxn ang="0">
+                    <a:pos x="connsiteX2" y="connsiteY2"/>
+                  </a:cxn>
+                  <a:cxn ang="0">
+                    <a:pos x="connsiteX3" y="connsiteY3"/>
+                  </a:cxn>
+                </a:cxnLst>
+                <a:rect l="l" t="t" r="r" b="b"/>
+                <a:pathLst>
+                  <a:path w="276225" h="47625">
+                    <a:moveTo>
+                      <a:pt x="7144" y="7144"/>
+                    </a:moveTo>
+                    <a:lnTo>
+                      <a:pt x="273844" y="7144"/>
+                    </a:lnTo>
+                    <a:lnTo>
+                      <a:pt x="273844" y="45244"/>
+                    </a:lnTo>
+                    <a:lnTo>
+                      <a:pt x="7144" y="45244"/>
+                    </a:lnTo>
+                    <a:close/>
+                  </a:path>
+                </a:pathLst>
+              </a:custGeom>
+              <a:solidFill>
+                <a:schemeClr val="bg1">
+                  <a:lumMod val="65000"/>
+                </a:schemeClr>
+              </a:solidFill>
+              <a:ln w="9525" cap="flat">
+                <a:noFill/>
+                <a:prstDash val="solid"/>
+                <a:miter/>
+              </a:ln>
+            </p:spPr>
+            <p:txBody>
+              <a:bodyPr rtlCol="0" anchor="ctr"/>
+              <a:lstStyle/>
+              <a:p>
+                <a:endParaRPr lang="en-US"/>
+              </a:p>
+            </p:txBody>
+          </p:sp>
+        </p:grpSp>
+        <p:sp>
+          <p:nvSpPr>
+            <p:cNvPr id="80" name="Rectangle 79">
+              <a:extLst>
+                <a:ext uri="{FF2B5EF4-FFF2-40B4-BE49-F238E27FC236}">
+                  <a16:creationId xmlns:a16="http://schemas.microsoft.com/office/drawing/2014/main" id="{D6006889-16D6-4FD5-8856-5E1F3CF6CFC0}"/>
+                </a:ext>
+              </a:extLst>
+            </p:cNvPr>
+            <p:cNvSpPr/>
+            <p:nvPr/>
+          </p:nvSpPr>
+          <p:spPr>
+            <a:xfrm>
+              <a:off x="8915146" y="3165039"/>
+              <a:ext cx="45719" cy="195397"/>
+            </a:xfrm>
+            <a:prstGeom prst="rect">
+              <a:avLst/>
+            </a:prstGeom>
+            <a:solidFill>
+              <a:schemeClr val="tx1"/>
+            </a:solidFill>
+            <a:ln>
+              <a:noFill/>
+            </a:ln>
+          </p:spPr>
+          <p:style>
+            <a:lnRef idx="2">
+              <a:schemeClr val="accent1">
+                <a:shade val="50000"/>
+              </a:schemeClr>
+            </a:lnRef>
+            <a:fillRef idx="1">
+              <a:schemeClr val="accent1"/>
+            </a:fillRef>
+            <a:effectRef idx="0">
+              <a:schemeClr val="accent1"/>
+            </a:effectRef>
+            <a:fontRef idx="minor">
+              <a:schemeClr val="lt1"/>
+            </a:fontRef>
+          </p:style>
+          <p:txBody>
+            <a:bodyPr rtlCol="0" anchor="ctr"/>
+            <a:lstStyle/>
+            <a:p>
+              <a:pPr algn="ctr"/>
+              <a:endParaRPr lang="en-US"/>
+            </a:p>
+          </p:txBody>
+        </p:sp>
+        <p:sp>
+          <p:nvSpPr>
+            <p:cNvPr id="79" name="Graphic 25" descr="Warning">
+              <a:extLst>
+                <a:ext uri="{FF2B5EF4-FFF2-40B4-BE49-F238E27FC236}">
+                  <a16:creationId xmlns:a16="http://schemas.microsoft.com/office/drawing/2014/main" id="{2108F5EA-C7E9-4FA0-9270-A9392BD09878}"/>
+                </a:ext>
+              </a:extLst>
+            </p:cNvPr>
+            <p:cNvSpPr/>
+            <p:nvPr/>
+          </p:nvSpPr>
+          <p:spPr>
+            <a:xfrm>
+              <a:off x="8799894" y="3105555"/>
+              <a:ext cx="276225" cy="271463"/>
+            </a:xfrm>
+            <a:custGeom>
+              <a:avLst/>
+              <a:gdLst>
+                <a:gd name="connsiteX0" fmla="*/ 341544 w 341403"/>
+                <a:gd name="connsiteY0" fmla="*/ 279227 h 301705"/>
+                <a:gd name="connsiteX1" fmla="*/ 186325 w 341403"/>
+                <a:gd name="connsiteY1" fmla="*/ 9279 h 301705"/>
+                <a:gd name="connsiteX2" fmla="*/ 158933 w 341403"/>
+                <a:gd name="connsiteY2" fmla="*/ 9279 h 301705"/>
+                <a:gd name="connsiteX3" fmla="*/ 3316 w 341403"/>
+                <a:gd name="connsiteY3" fmla="*/ 279227 h 301705"/>
+                <a:gd name="connsiteX4" fmla="*/ 17211 w 341403"/>
+                <a:gd name="connsiteY4" fmla="*/ 303046 h 301705"/>
+                <a:gd name="connsiteX5" fmla="*/ 172430 w 341403"/>
+                <a:gd name="connsiteY5" fmla="*/ 303046 h 301705"/>
+                <a:gd name="connsiteX6" fmla="*/ 327650 w 341403"/>
+                <a:gd name="connsiteY6" fmla="*/ 303046 h 301705"/>
+                <a:gd name="connsiteX7" fmla="*/ 341544 w 341403"/>
+                <a:gd name="connsiteY7" fmla="*/ 279227 h 301705"/>
+                <a:gd name="connsiteX8" fmla="*/ 160521 w 341403"/>
+                <a:gd name="connsiteY8" fmla="*/ 72796 h 301705"/>
+                <a:gd name="connsiteX9" fmla="*/ 184340 w 341403"/>
+                <a:gd name="connsiteY9" fmla="*/ 72796 h 301705"/>
+                <a:gd name="connsiteX10" fmla="*/ 184340 w 341403"/>
+                <a:gd name="connsiteY10" fmla="*/ 211740 h 301705"/>
+                <a:gd name="connsiteX11" fmla="*/ 160521 w 341403"/>
+                <a:gd name="connsiteY11" fmla="*/ 211740 h 301705"/>
+                <a:gd name="connsiteX12" fmla="*/ 160521 w 341403"/>
+                <a:gd name="connsiteY12" fmla="*/ 72796 h 301705"/>
+                <a:gd name="connsiteX13" fmla="*/ 172430 w 341403"/>
+                <a:gd name="connsiteY13" fmla="*/ 267317 h 301705"/>
+                <a:gd name="connsiteX14" fmla="*/ 152581 w 341403"/>
+                <a:gd name="connsiteY14" fmla="*/ 247468 h 301705"/>
+                <a:gd name="connsiteX15" fmla="*/ 172430 w 341403"/>
+                <a:gd name="connsiteY15" fmla="*/ 227619 h 301705"/>
+                <a:gd name="connsiteX16" fmla="*/ 192279 w 341403"/>
+                <a:gd name="connsiteY16" fmla="*/ 247468 h 301705"/>
+                <a:gd name="connsiteX17" fmla="*/ 172430 w 341403"/>
+                <a:gd name="connsiteY17" fmla="*/ 267317 h 301705"/>
+              </a:gdLst>
+              <a:ahLst/>
+              <a:cxnLst>
+                <a:cxn ang="0">
+                  <a:pos x="connsiteX0" y="connsiteY0"/>
+                </a:cxn>
+                <a:cxn ang="0">
+                  <a:pos x="connsiteX1" y="connsiteY1"/>
+                </a:cxn>
+                <a:cxn ang="0">
+                  <a:pos x="connsiteX2" y="connsiteY2"/>
+                </a:cxn>
+                <a:cxn ang="0">
+                  <a:pos x="connsiteX3" y="connsiteY3"/>
+                </a:cxn>
+                <a:cxn ang="0">
+                  <a:pos x="connsiteX4" y="connsiteY4"/>
+                </a:cxn>
+                <a:cxn ang="0">
+                  <a:pos x="connsiteX5" y="connsiteY5"/>
+                </a:cxn>
+                <a:cxn ang="0">
+                  <a:pos x="connsiteX6" y="connsiteY6"/>
+                </a:cxn>
+                <a:cxn ang="0">
+                  <a:pos x="connsiteX7" y="connsiteY7"/>
+                </a:cxn>
+                <a:cxn ang="0">
+                  <a:pos x="connsiteX8" y="connsiteY8"/>
+                </a:cxn>
+                <a:cxn ang="0">
+                  <a:pos x="connsiteX9" y="connsiteY9"/>
+                </a:cxn>
+                <a:cxn ang="0">
+                  <a:pos x="connsiteX10" y="connsiteY10"/>
+                </a:cxn>
+                <a:cxn ang="0">
+                  <a:pos x="connsiteX11" y="connsiteY11"/>
+                </a:cxn>
+                <a:cxn ang="0">
+                  <a:pos x="connsiteX12" y="connsiteY12"/>
+                </a:cxn>
+                <a:cxn ang="0">
+                  <a:pos x="connsiteX13" y="connsiteY13"/>
+                </a:cxn>
+                <a:cxn ang="0">
+                  <a:pos x="connsiteX14" y="connsiteY14"/>
+                </a:cxn>
+                <a:cxn ang="0">
+                  <a:pos x="connsiteX15" y="connsiteY15"/>
+                </a:cxn>
+                <a:cxn ang="0">
+                  <a:pos x="connsiteX16" y="connsiteY16"/>
+                </a:cxn>
+                <a:cxn ang="0">
+                  <a:pos x="connsiteX17" y="connsiteY17"/>
+                </a:cxn>
+              </a:cxnLst>
+              <a:rect l="l" t="t" r="r" b="b"/>
+              <a:pathLst>
+                <a:path w="341403" h="301705">
+                  <a:moveTo>
+                    <a:pt x="341544" y="279227"/>
+                  </a:moveTo>
+                  <a:lnTo>
+                    <a:pt x="186325" y="9279"/>
+                  </a:lnTo>
+                  <a:cubicBezTo>
+                    <a:pt x="180370" y="-1439"/>
+                    <a:pt x="164888" y="-1439"/>
+                    <a:pt x="158933" y="9279"/>
+                  </a:cubicBezTo>
+                  <a:lnTo>
+                    <a:pt x="3316" y="279227"/>
+                  </a:lnTo>
+                  <a:cubicBezTo>
+                    <a:pt x="-2638" y="289945"/>
+                    <a:pt x="4904" y="303046"/>
+                    <a:pt x="17211" y="303046"/>
+                  </a:cubicBezTo>
+                  <a:lnTo>
+                    <a:pt x="172430" y="303046"/>
+                  </a:lnTo>
+                  <a:lnTo>
+                    <a:pt x="327650" y="303046"/>
+                  </a:lnTo>
+                  <a:cubicBezTo>
+                    <a:pt x="339956" y="303046"/>
+                    <a:pt x="347499" y="289945"/>
+                    <a:pt x="341544" y="279227"/>
+                  </a:cubicBezTo>
+                  <a:close/>
+                  <a:moveTo>
+                    <a:pt x="160521" y="72796"/>
+                  </a:moveTo>
+                  <a:lnTo>
+                    <a:pt x="184340" y="72796"/>
+                  </a:lnTo>
+                  <a:lnTo>
+                    <a:pt x="184340" y="211740"/>
+                  </a:lnTo>
+                  <a:lnTo>
+                    <a:pt x="160521" y="211740"/>
+                  </a:lnTo>
+                  <a:lnTo>
+                    <a:pt x="160521" y="72796"/>
+                  </a:lnTo>
+                  <a:close/>
+                  <a:moveTo>
+                    <a:pt x="172430" y="267317"/>
+                  </a:moveTo>
+                  <a:cubicBezTo>
+                    <a:pt x="161315" y="267317"/>
+                    <a:pt x="152581" y="258584"/>
+                    <a:pt x="152581" y="247468"/>
+                  </a:cubicBezTo>
+                  <a:cubicBezTo>
+                    <a:pt x="152581" y="236353"/>
+                    <a:pt x="161315" y="227619"/>
+                    <a:pt x="172430" y="227619"/>
+                  </a:cubicBezTo>
+                  <a:cubicBezTo>
+                    <a:pt x="183546" y="227619"/>
+                    <a:pt x="192279" y="236353"/>
+                    <a:pt x="192279" y="247468"/>
+                  </a:cubicBezTo>
+                  <a:cubicBezTo>
+                    <a:pt x="192279" y="258584"/>
+                    <a:pt x="183546" y="267317"/>
+                    <a:pt x="172430" y="267317"/>
+                  </a:cubicBezTo>
+                  <a:close/>
+                </a:path>
+              </a:pathLst>
+            </a:custGeom>
+            <a:solidFill>
+              <a:srgbClr val="FFFF00"/>
+            </a:solidFill>
+            <a:ln w="3969" cap="flat">
+              <a:noFill/>
+              <a:prstDash val="solid"/>
+              <a:miter/>
+            </a:ln>
+            <a:effectLst/>
+          </p:spPr>
+          <p:txBody>
+            <a:bodyPr rtlCol="0" anchor="ctr"/>
+            <a:lstStyle/>
+            <a:p>
+              <a:endParaRPr lang="en-US" dirty="0"/>
+            </a:p>
+          </p:txBody>
+        </p:sp>
       </p:grpSp>
     </p:spTree>
     <p:extLst>

</xml_diff>